<commit_message>
feat: clean 9-slide deck - each readable in 5 seconds
</commit_message>
<xml_diff>
--- a/sales/Sentinel_Ops_Sales_Deck.pptx
+++ b/sales/Sentinel_Ops_Sales_Deck.pptx
@@ -3112,8 +3112,8 @@
         </p:nvSpPr>
         <p:spPr>
           <a:xfrm>
-            <a:off x="640080" y="1188720"/>
-            <a:ext cx="10972800" cy="1097280"/>
+            <a:off x="640080" y="1280160"/>
+            <a:ext cx="10972800" cy="1188720"/>
           </a:xfrm>
           <a:prstGeom prst="rect">
             <a:avLst/>
@@ -3128,7 +3128,7 @@
           <a:p>
             <a:pPr algn="l"/>
             <a:r>
-              <a:rPr sz="6800" b="1" i="0">
+              <a:rPr sz="7200" b="1" i="0">
                 <a:solidFill>
                   <a:srgbClr val="FFFFFF"/>
                 </a:solidFill>
@@ -3146,8 +3146,8 @@
         </p:nvSpPr>
         <p:spPr>
           <a:xfrm>
-            <a:off x="640080" y="2377440"/>
-            <a:ext cx="10972800" cy="640080"/>
+            <a:off x="640080" y="2560320"/>
+            <a:ext cx="10972800" cy="548640"/>
           </a:xfrm>
           <a:prstGeom prst="rect">
             <a:avLst/>
@@ -3162,12 +3162,12 @@
           <a:p>
             <a:pPr algn="l"/>
             <a:r>
-              <a:rPr sz="3000" b="0" i="0">
+              <a:rPr sz="2600" b="0" i="0">
                 <a:solidFill>
                   <a:srgbClr val="22C55E"/>
                 </a:solidFill>
               </a:rPr>
-              <a:t>Lean Managed Cybersecurity</a:t>
+              <a:t>Lean Managed Cybersecurity for Malaysian SMEs</a:t>
             </a:r>
           </a:p>
         </p:txBody>
@@ -3180,8 +3180,8 @@
         </p:nvSpPr>
         <p:spPr>
           <a:xfrm>
-            <a:off x="640080" y="2926080"/>
-            <a:ext cx="10972800" cy="548640"/>
+            <a:off x="640080" y="3154680"/>
+            <a:ext cx="10972800" cy="411480"/>
           </a:xfrm>
           <a:prstGeom prst="rect">
             <a:avLst/>
@@ -3196,26 +3196,60 @@
           <a:p>
             <a:pPr algn="l"/>
             <a:r>
-              <a:rPr sz="2600" b="0" i="0">
-                <a:solidFill>
-                  <a:srgbClr val="CBD5E1"/>
-                </a:solidFill>
-              </a:rPr>
-              <a:t>for Malaysian SMEs &amp; Growing Teams</a:t>
-            </a:r>
-          </a:p>
-        </p:txBody>
-      </p:sp>
-      <p:sp>
-        <p:nvSpPr>
-          <p:cNvPr id="5" name="Rectangle 4"/>
+              <a:rPr sz="1600" b="0" i="0">
+                <a:solidFill>
+                  <a:srgbClr val="94A3B8"/>
+                </a:solidFill>
+              </a:rPr>
+              <a:t>Monitoring  •  Hardening  •  Audit-Ready Reporting</a:t>
+            </a:r>
+          </a:p>
+        </p:txBody>
+      </p:sp>
+      <p:sp>
+        <p:nvSpPr>
+          <p:cNvPr id="5" name="TextBox 4"/>
+          <p:cNvSpPr txBox="1"/>
+          <p:nvPr/>
+        </p:nvSpPr>
+        <p:spPr>
+          <a:xfrm>
+            <a:off x="640080" y="3566160"/>
+            <a:ext cx="10972800" cy="411480"/>
+          </a:xfrm>
+          <a:prstGeom prst="rect">
+            <a:avLst/>
+          </a:prstGeom>
+          <a:noFill/>
+        </p:spPr>
+        <p:txBody>
+          <a:bodyPr wrap="square">
+            <a:spAutoFit/>
+          </a:bodyPr>
+          <a:lstStyle/>
+          <a:p>
+            <a:pPr algn="l"/>
+            <a:r>
+              <a:rPr sz="1600" b="0" i="0">
+                <a:solidFill>
+                  <a:srgbClr val="94A3B8"/>
+                </a:solidFill>
+              </a:rPr>
+              <a:t>without building a full SOC.</a:t>
+            </a:r>
+          </a:p>
+        </p:txBody>
+      </p:sp>
+      <p:sp>
+        <p:nvSpPr>
+          <p:cNvPr id="6" name="Rectangle 5"/>
           <p:cNvSpPr/>
           <p:nvPr/>
         </p:nvSpPr>
         <p:spPr>
           <a:xfrm>
-            <a:off x="640080" y="3657600"/>
-            <a:ext cx="3657600" cy="38100"/>
+            <a:off x="640080" y="4114800"/>
+            <a:ext cx="3200400" cy="38100"/>
           </a:xfrm>
           <a:prstGeom prst="rect">
             <a:avLst/>
@@ -3251,13 +3285,13 @@
       </p:sp>
       <p:sp>
         <p:nvSpPr>
-          <p:cNvPr id="6" name="TextBox 5"/>
+          <p:cNvPr id="7" name="TextBox 6"/>
           <p:cNvSpPr txBox="1"/>
           <p:nvPr/>
         </p:nvSpPr>
         <p:spPr>
           <a:xfrm>
-            <a:off x="640080" y="3886200"/>
+            <a:off x="640080" y="4389120"/>
             <a:ext cx="10972800" cy="457200"/>
           </a:xfrm>
           <a:prstGeom prst="rect">
@@ -3273,26 +3307,26 @@
           <a:p>
             <a:pPr algn="l"/>
             <a:r>
-              <a:rPr sz="1600" b="0" i="0">
-                <a:solidFill>
-                  <a:srgbClr val="CBD5E1"/>
-                </a:solidFill>
-              </a:rPr>
-              <a:t>Monitoring  •  Hardening  •  Audit-Ready Reporting</a:t>
-            </a:r>
-          </a:p>
-        </p:txBody>
-      </p:sp>
-      <p:sp>
-        <p:nvSpPr>
-          <p:cNvPr id="7" name="TextBox 6"/>
+              <a:rPr sz="2000" b="1" i="0">
+                <a:solidFill>
+                  <a:srgbClr val="FFFFFF"/>
+                </a:solidFill>
+              </a:rPr>
+              <a:t>[Your Name]</a:t>
+            </a:r>
+          </a:p>
+        </p:txBody>
+      </p:sp>
+      <p:sp>
+        <p:nvSpPr>
+          <p:cNvPr id="8" name="TextBox 7"/>
           <p:cNvSpPr txBox="1"/>
           <p:nvPr/>
         </p:nvSpPr>
         <p:spPr>
           <a:xfrm>
-            <a:off x="640080" y="4297680"/>
-            <a:ext cx="10972800" cy="457200"/>
+            <a:off x="640080" y="4800600"/>
+            <a:ext cx="10972800" cy="365760"/>
           </a:xfrm>
           <a:prstGeom prst="rect">
             <a:avLst/>
@@ -3307,26 +3341,26 @@
           <a:p>
             <a:pPr algn="l"/>
             <a:r>
-              <a:rPr sz="1600" b="0" i="0">
-                <a:solidFill>
-                  <a:srgbClr val="CBD5E1"/>
-                </a:solidFill>
-              </a:rPr>
-              <a:t>without building a full SOC.</a:t>
-            </a:r>
-          </a:p>
-        </p:txBody>
-      </p:sp>
-      <p:sp>
-        <p:nvSpPr>
-          <p:cNvPr id="8" name="TextBox 7"/>
+              <a:rPr sz="1400" b="0" i="0">
+                <a:solidFill>
+                  <a:srgbClr val="94A3B8"/>
+                </a:solidFill>
+              </a:rPr>
+              <a:t>Founder / Operator, Sentinel Ops</a:t>
+            </a:r>
+          </a:p>
+        </p:txBody>
+      </p:sp>
+      <p:sp>
+        <p:nvSpPr>
+          <p:cNvPr id="9" name="TextBox 8"/>
           <p:cNvSpPr txBox="1"/>
           <p:nvPr/>
         </p:nvSpPr>
         <p:spPr>
           <a:xfrm>
-            <a:off x="640080" y="5120640"/>
-            <a:ext cx="10972800" cy="411480"/>
+            <a:off x="640080" y="5166360"/>
+            <a:ext cx="10972800" cy="320040"/>
           </a:xfrm>
           <a:prstGeom prst="rect">
             <a:avLst/>
@@ -3341,80 +3375,12 @@
           <a:p>
             <a:pPr algn="l"/>
             <a:r>
-              <a:rPr sz="1800" b="1" i="0">
-                <a:solidFill>
-                  <a:srgbClr val="FFFFFF"/>
-                </a:solidFill>
-              </a:rPr>
-              <a:t>[Your Name]</a:t>
-            </a:r>
-          </a:p>
-        </p:txBody>
-      </p:sp>
-      <p:sp>
-        <p:nvSpPr>
-          <p:cNvPr id="9" name="TextBox 8"/>
-          <p:cNvSpPr txBox="1"/>
-          <p:nvPr/>
-        </p:nvSpPr>
-        <p:spPr>
-          <a:xfrm>
-            <a:off x="640080" y="5486400"/>
-            <a:ext cx="10972800" cy="365760"/>
-          </a:xfrm>
-          <a:prstGeom prst="rect">
-            <a:avLst/>
-          </a:prstGeom>
-          <a:noFill/>
-        </p:spPr>
-        <p:txBody>
-          <a:bodyPr wrap="square">
-            <a:spAutoFit/>
-          </a:bodyPr>
-          <a:lstStyle/>
-          <a:p>
-            <a:pPr algn="l"/>
-            <a:r>
-              <a:rPr sz="1400" b="0" i="0">
-                <a:solidFill>
-                  <a:srgbClr val="CBD5E1"/>
-                </a:solidFill>
-              </a:rPr>
-              <a:t>Founder / Operator  •  Sentinel Ops</a:t>
-            </a:r>
-          </a:p>
-        </p:txBody>
-      </p:sp>
-      <p:sp>
-        <p:nvSpPr>
-          <p:cNvPr id="10" name="TextBox 9"/>
-          <p:cNvSpPr txBox="1"/>
-          <p:nvPr/>
-        </p:nvSpPr>
-        <p:spPr>
-          <a:xfrm>
-            <a:off x="640080" y="5897880"/>
-            <a:ext cx="10972800" cy="320040"/>
-          </a:xfrm>
-          <a:prstGeom prst="rect">
-            <a:avLst/>
-          </a:prstGeom>
-          <a:noFill/>
-        </p:spPr>
-        <p:txBody>
-          <a:bodyPr wrap="square">
-            <a:spAutoFit/>
-          </a:bodyPr>
-          <a:lstStyle/>
-          <a:p>
-            <a:pPr algn="l"/>
-            <a:r>
               <a:rPr sz="1300" b="0" i="0">
                 <a:solidFill>
                   <a:srgbClr val="608090"/>
                 </a:solidFill>
               </a:rPr>
-              <a:t>[email@]   [WhatsApp]   [LinkedIn]</a:t>
+              <a:t>[email]   [WhatsApp]   [LinkedIn]</a:t>
             </a:r>
           </a:p>
         </p:txBody>
@@ -3453,8 +3419,8 @@
         </p:nvSpPr>
         <p:spPr>
           <a:xfrm>
-            <a:off x="548640" y="228600"/>
-            <a:ext cx="10972800" cy="640080"/>
+            <a:off x="548640" y="256032"/>
+            <a:ext cx="10972800" cy="731520"/>
           </a:xfrm>
           <a:prstGeom prst="rect">
             <a:avLst/>
@@ -3469,7 +3435,7 @@
           <a:p>
             <a:pPr algn="l"/>
             <a:r>
-              <a:rPr sz="3000" b="1" i="0">
+              <a:rPr sz="3200" b="1" i="0">
                 <a:solidFill>
                   <a:srgbClr val="F8FAFC"/>
                 </a:solidFill>
@@ -3487,8 +3453,8 @@
         </p:nvSpPr>
         <p:spPr>
           <a:xfrm>
-            <a:off x="548640" y="749808"/>
-            <a:ext cx="10972800" cy="320040"/>
+            <a:off x="548640" y="868680"/>
+            <a:ext cx="10972800" cy="365760"/>
           </a:xfrm>
           <a:prstGeom prst="rect">
             <a:avLst/>
@@ -3505,10 +3471,10 @@
             <a:r>
               <a:rPr sz="1400" b="0" i="0">
                 <a:solidFill>
-                  <a:srgbClr val="CBD5E1"/>
-                </a:solidFill>
-              </a:rPr>
-              <a:t>Why growing companies struggle with cybersecurity operations</a:t>
+                  <a:srgbClr val="94A3B8"/>
+                </a:solidFill>
+              </a:rPr>
+              <a:t>Why growing companies struggle with cybersecurity</a:t>
             </a:r>
           </a:p>
         </p:txBody>
@@ -3521,7 +3487,7 @@
         </p:nvSpPr>
         <p:spPr>
           <a:xfrm>
-            <a:off x="548640" y="1078992"/>
+            <a:off x="548640" y="1207008"/>
             <a:ext cx="11064240" cy="38100"/>
           </a:xfrm>
           <a:prstGeom prst="rect">
@@ -3558,14 +3524,65 @@
       </p:sp>
       <p:sp>
         <p:nvSpPr>
-          <p:cNvPr id="5" name="TextBox 4"/>
+          <p:cNvPr id="5" name="Rectangle 4"/>
+          <p:cNvSpPr/>
+          <p:nvPr/>
+        </p:nvSpPr>
+        <p:spPr>
+          <a:xfrm>
+            <a:off x="452628" y="1508760"/>
+            <a:ext cx="2560320" cy="411480"/>
+          </a:xfrm>
+          <a:prstGeom prst="rect">
+            <a:avLst/>
+          </a:prstGeom>
+          <a:solidFill>
+            <a:srgbClr val="22C55E"/>
+          </a:solidFill>
+          <a:ln>
+            <a:noFill/>
+          </a:ln>
+        </p:spPr>
+        <p:style>
+          <a:lnRef idx="1">
+            <a:schemeClr val="accent1"/>
+          </a:lnRef>
+          <a:fillRef idx="3">
+            <a:schemeClr val="accent1"/>
+          </a:fillRef>
+          <a:effectRef idx="2">
+            <a:schemeClr val="accent1"/>
+          </a:effectRef>
+          <a:fontRef idx="minor">
+            <a:schemeClr val="lt1"/>
+          </a:fontRef>
+        </p:style>
+        <p:txBody>
+          <a:bodyPr rtlCol="0" anchor="ctr"/>
+          <a:lstStyle/>
+          <a:p>
+            <a:pPr algn="ctr"/>
+            <a:r>
+              <a:rPr sz="1200" b="1">
+                <a:solidFill>
+                  <a:srgbClr val="FFFFFF"/>
+                </a:solidFill>
+              </a:rPr>
+              <a:t>Noise, not signal</a:t>
+            </a:r>
+          </a:p>
+        </p:txBody>
+      </p:sp>
+      <p:sp>
+        <p:nvSpPr>
+          <p:cNvPr id="6" name="TextBox 5"/>
           <p:cNvSpPr txBox="1"/>
           <p:nvPr/>
         </p:nvSpPr>
         <p:spPr>
           <a:xfrm>
-            <a:off x="548640" y="1371600"/>
-            <a:ext cx="2468880" cy="365760"/>
+            <a:off x="452628" y="2011680"/>
+            <a:ext cx="2560320" cy="1280160"/>
           </a:xfrm>
           <a:prstGeom prst="rect">
             <a:avLst/>
@@ -3580,26 +3597,78 @@
           <a:p>
             <a:pPr algn="l"/>
             <a:r>
-              <a:rPr sz="1300" b="1" i="0">
-                <a:solidFill>
-                  <a:srgbClr val="22C55E"/>
-                </a:solidFill>
-              </a:rPr>
-              <a:t>Noise, not signal</a:t>
-            </a:r>
-          </a:p>
-        </p:txBody>
-      </p:sp>
-      <p:sp>
-        <p:nvSpPr>
-          <p:cNvPr id="6" name="TextBox 5"/>
+              <a:rPr sz="1400" b="0" i="0">
+                <a:solidFill>
+                  <a:srgbClr val="F8FAFC"/>
+                </a:solidFill>
+              </a:rPr>
+              <a:t>Security tools fire alerts.
+Nobody triages them.</a:t>
+            </a:r>
+          </a:p>
+        </p:txBody>
+      </p:sp>
+      <p:sp>
+        <p:nvSpPr>
+          <p:cNvPr id="7" name="Rectangle 6"/>
+          <p:cNvSpPr/>
+          <p:nvPr/>
+        </p:nvSpPr>
+        <p:spPr>
+          <a:xfrm>
+            <a:off x="3360420" y="1508760"/>
+            <a:ext cx="2560320" cy="411480"/>
+          </a:xfrm>
+          <a:prstGeom prst="rect">
+            <a:avLst/>
+          </a:prstGeom>
+          <a:solidFill>
+            <a:srgbClr val="38BDF8"/>
+          </a:solidFill>
+          <a:ln>
+            <a:noFill/>
+          </a:ln>
+        </p:spPr>
+        <p:style>
+          <a:lnRef idx="1">
+            <a:schemeClr val="accent1"/>
+          </a:lnRef>
+          <a:fillRef idx="3">
+            <a:schemeClr val="accent1"/>
+          </a:fillRef>
+          <a:effectRef idx="2">
+            <a:schemeClr val="accent1"/>
+          </a:effectRef>
+          <a:fontRef idx="minor">
+            <a:schemeClr val="lt1"/>
+          </a:fontRef>
+        </p:style>
+        <p:txBody>
+          <a:bodyPr rtlCol="0" anchor="ctr"/>
+          <a:lstStyle/>
+          <a:p>
+            <a:pPr algn="ctr"/>
+            <a:r>
+              <a:rPr sz="1200" b="1">
+                <a:solidFill>
+                  <a:srgbClr val="FFFFFF"/>
+                </a:solidFill>
+              </a:rPr>
+              <a:t>No time</a:t>
+            </a:r>
+          </a:p>
+        </p:txBody>
+      </p:sp>
+      <p:sp>
+        <p:nvSpPr>
+          <p:cNvPr id="8" name="TextBox 7"/>
           <p:cNvSpPr txBox="1"/>
           <p:nvPr/>
         </p:nvSpPr>
         <p:spPr>
           <a:xfrm>
-            <a:off x="548640" y="1737360"/>
-            <a:ext cx="2468880" cy="3657600"/>
+            <a:off x="3360420" y="2011680"/>
+            <a:ext cx="2560320" cy="1280160"/>
           </a:xfrm>
           <a:prstGeom prst="rect">
             <a:avLst/>
@@ -3612,47 +3681,80 @@
           </a:bodyPr>
           <a:lstStyle/>
           <a:p>
-            <a:pPr>
-              <a:spcBef>
-                <a:spcPts val="600"/>
-              </a:spcBef>
-            </a:pPr>
-            <a:r>
-              <a:rPr sz="1300">
+            <a:pPr algn="l"/>
+            <a:r>
+              <a:rPr sz="1400" b="0" i="0">
                 <a:solidFill>
                   <a:srgbClr val="F8FAFC"/>
                 </a:solidFill>
               </a:rPr>
-              <a:t>• Security tools generate alerts that never get triaged</a:t>
-            </a:r>
-          </a:p>
-          <a:p>
-            <a:pPr>
-              <a:spcBef>
-                <a:spcPts val="600"/>
-              </a:spcBef>
-            </a:pPr>
-            <a:r>
-              <a:rPr sz="1300">
-                <a:solidFill>
-                  <a:srgbClr val="F8FAFC"/>
-                </a:solidFill>
-              </a:rPr>
-              <a:t>• IT teams spend time on noise instead of real issues</a:t>
-            </a:r>
-          </a:p>
-        </p:txBody>
-      </p:sp>
-      <p:sp>
-        <p:nvSpPr>
-          <p:cNvPr id="7" name="TextBox 6"/>
+              <a:t>Small IT teams are fighting
+fires, not security.</a:t>
+            </a:r>
+          </a:p>
+        </p:txBody>
+      </p:sp>
+      <p:sp>
+        <p:nvSpPr>
+          <p:cNvPr id="9" name="Rectangle 8"/>
+          <p:cNvSpPr/>
+          <p:nvPr/>
+        </p:nvSpPr>
+        <p:spPr>
+          <a:xfrm>
+            <a:off x="6268212" y="1508760"/>
+            <a:ext cx="2560320" cy="411480"/>
+          </a:xfrm>
+          <a:prstGeom prst="rect">
+            <a:avLst/>
+          </a:prstGeom>
+          <a:solidFill>
+            <a:srgbClr val="00B88A"/>
+          </a:solidFill>
+          <a:ln>
+            <a:noFill/>
+          </a:ln>
+        </p:spPr>
+        <p:style>
+          <a:lnRef idx="1">
+            <a:schemeClr val="accent1"/>
+          </a:lnRef>
+          <a:fillRef idx="3">
+            <a:schemeClr val="accent1"/>
+          </a:fillRef>
+          <a:effectRef idx="2">
+            <a:schemeClr val="accent1"/>
+          </a:effectRef>
+          <a:fontRef idx="minor">
+            <a:schemeClr val="lt1"/>
+          </a:fontRef>
+        </p:style>
+        <p:txBody>
+          <a:bodyPr rtlCol="0" anchor="ctr"/>
+          <a:lstStyle/>
+          <a:p>
+            <a:pPr algn="ctr"/>
+            <a:r>
+              <a:rPr sz="1200" b="1">
+                <a:solidFill>
+                  <a:srgbClr val="FFFFFF"/>
+                </a:solidFill>
+              </a:rPr>
+              <a:t>Inconsistent hygiene</a:t>
+            </a:r>
+          </a:p>
+        </p:txBody>
+      </p:sp>
+      <p:sp>
+        <p:nvSpPr>
+          <p:cNvPr id="10" name="TextBox 9"/>
           <p:cNvSpPr txBox="1"/>
           <p:nvPr/>
         </p:nvSpPr>
         <p:spPr>
           <a:xfrm>
-            <a:off x="3291840" y="1371600"/>
-            <a:ext cx="2468880" cy="365760"/>
+            <a:off x="6268212" y="2011680"/>
+            <a:ext cx="2560320" cy="1280160"/>
           </a:xfrm>
           <a:prstGeom prst="rect">
             <a:avLst/>
@@ -3667,26 +3769,78 @@
           <a:p>
             <a:pPr algn="l"/>
             <a:r>
-              <a:rPr sz="1300" b="1" i="0">
-                <a:solidFill>
-                  <a:srgbClr val="22C55E"/>
-                </a:solidFill>
-              </a:rPr>
-              <a:t>Inconsistent hygiene</a:t>
-            </a:r>
-          </a:p>
-        </p:txBody>
-      </p:sp>
-      <p:sp>
-        <p:nvSpPr>
-          <p:cNvPr id="8" name="TextBox 7"/>
+              <a:rPr sz="1400" b="0" i="0">
+                <a:solidFill>
+                  <a:srgbClr val="F8FAFC"/>
+                </a:solidFill>
+              </a:rPr>
+              <a:t>Hardening falls off the
+priority list.</a:t>
+            </a:r>
+          </a:p>
+        </p:txBody>
+      </p:sp>
+      <p:sp>
+        <p:nvSpPr>
+          <p:cNvPr id="11" name="Rectangle 10"/>
+          <p:cNvSpPr/>
+          <p:nvPr/>
+        </p:nvSpPr>
+        <p:spPr>
+          <a:xfrm>
+            <a:off x="9176004" y="1508760"/>
+            <a:ext cx="2560320" cy="411480"/>
+          </a:xfrm>
+          <a:prstGeom prst="rect">
+            <a:avLst/>
+          </a:prstGeom>
+          <a:solidFill>
+            <a:srgbClr val="A78AF5"/>
+          </a:solidFill>
+          <a:ln>
+            <a:noFill/>
+          </a:ln>
+        </p:spPr>
+        <p:style>
+          <a:lnRef idx="1">
+            <a:schemeClr val="accent1"/>
+          </a:lnRef>
+          <a:fillRef idx="3">
+            <a:schemeClr val="accent1"/>
+          </a:fillRef>
+          <a:effectRef idx="2">
+            <a:schemeClr val="accent1"/>
+          </a:effectRef>
+          <a:fontRef idx="minor">
+            <a:schemeClr val="lt1"/>
+          </a:fontRef>
+        </p:style>
+        <p:txBody>
+          <a:bodyPr rtlCol="0" anchor="ctr"/>
+          <a:lstStyle/>
+          <a:p>
+            <a:pPr algn="ctr"/>
+            <a:r>
+              <a:rPr sz="1200" b="1">
+                <a:solidFill>
+                  <a:srgbClr val="FFFFFF"/>
+                </a:solidFill>
+              </a:rPr>
+              <a:t>Compliance rising</a:t>
+            </a:r>
+          </a:p>
+        </p:txBody>
+      </p:sp>
+      <p:sp>
+        <p:nvSpPr>
+          <p:cNvPr id="12" name="TextBox 11"/>
           <p:cNvSpPr txBox="1"/>
           <p:nvPr/>
         </p:nvSpPr>
         <p:spPr>
           <a:xfrm>
-            <a:off x="3291840" y="1737360"/>
-            <a:ext cx="2468880" cy="3657600"/>
+            <a:off x="9176004" y="2011680"/>
+            <a:ext cx="2560320" cy="1280160"/>
           </a:xfrm>
           <a:prstGeom prst="rect">
             <a:avLst/>
@@ -3699,237 +3853,15 @@
           </a:bodyPr>
           <a:lstStyle/>
           <a:p>
-            <a:pPr>
-              <a:spcBef>
-                <a:spcPts val="600"/>
-              </a:spcBef>
-            </a:pPr>
-            <a:r>
-              <a:rPr sz="1300">
+            <a:pPr algn="l"/>
+            <a:r>
+              <a:rPr sz="1400" b="0" i="0">
                 <a:solidFill>
                   <a:srgbClr val="F8FAFC"/>
                 </a:solidFill>
               </a:rPr>
-              <a:t>• Hardening and patching falls off the priority list</a:t>
-            </a:r>
-          </a:p>
-          <a:p>
-            <a:pPr>
-              <a:spcBef>
-                <a:spcPts val="600"/>
-              </a:spcBef>
-            </a:pPr>
-            <a:r>
-              <a:rPr sz="1300">
-                <a:solidFill>
-                  <a:srgbClr val="F8FAFC"/>
-                </a:solidFill>
-              </a:rPr>
-              <a:t>• Systems drift from secure baseline over time</a:t>
-            </a:r>
-          </a:p>
-        </p:txBody>
-      </p:sp>
-      <p:sp>
-        <p:nvSpPr>
-          <p:cNvPr id="9" name="TextBox 8"/>
-          <p:cNvSpPr txBox="1"/>
-          <p:nvPr/>
-        </p:nvSpPr>
-        <p:spPr>
-          <a:xfrm>
-            <a:off x="6035040" y="1371600"/>
-            <a:ext cx="2468880" cy="365760"/>
-          </a:xfrm>
-          <a:prstGeom prst="rect">
-            <a:avLst/>
-          </a:prstGeom>
-          <a:noFill/>
-        </p:spPr>
-        <p:txBody>
-          <a:bodyPr wrap="square">
-            <a:spAutoFit/>
-          </a:bodyPr>
-          <a:lstStyle/>
-          <a:p>
-            <a:pPr algn="l"/>
-            <a:r>
-              <a:rPr sz="1300" b="1" i="0">
-                <a:solidFill>
-                  <a:srgbClr val="22C55E"/>
-                </a:solidFill>
-              </a:rPr>
-              <a:t>Compliance pressure rising</a:t>
-            </a:r>
-          </a:p>
-        </p:txBody>
-      </p:sp>
-      <p:sp>
-        <p:nvSpPr>
-          <p:cNvPr id="10" name="TextBox 9"/>
-          <p:cNvSpPr txBox="1"/>
-          <p:nvPr/>
-        </p:nvSpPr>
-        <p:spPr>
-          <a:xfrm>
-            <a:off x="6035040" y="1737360"/>
-            <a:ext cx="2468880" cy="3657600"/>
-          </a:xfrm>
-          <a:prstGeom prst="rect">
-            <a:avLst/>
-          </a:prstGeom>
-          <a:noFill/>
-        </p:spPr>
-        <p:txBody>
-          <a:bodyPr wrap="square">
-            <a:spAutoFit/>
-          </a:bodyPr>
-          <a:lstStyle/>
-          <a:p>
-            <a:pPr>
-              <a:spcBef>
-                <a:spcPts val="600"/>
-              </a:spcBef>
-            </a:pPr>
-            <a:r>
-              <a:rPr sz="1300">
-                <a:solidFill>
-                  <a:srgbClr val="F8FAFC"/>
-                </a:solidFill>
-              </a:rPr>
-              <a:t>• PDPA requires demonstrable controls on personal data</a:t>
-            </a:r>
-          </a:p>
-          <a:p>
-            <a:pPr>
-              <a:spcBef>
-                <a:spcPts val="600"/>
-              </a:spcBef>
-            </a:pPr>
-            <a:r>
-              <a:rPr sz="1300">
-                <a:solidFill>
-                  <a:srgbClr val="F8FAFC"/>
-                </a:solidFill>
-              </a:rPr>
-              <a:t>• Enterprise clients increasingly ask about security posture</a:t>
-            </a:r>
-          </a:p>
-          <a:p>
-            <a:pPr>
-              <a:spcBef>
-                <a:spcPts val="600"/>
-              </a:spcBef>
-            </a:pPr>
-            <a:r>
-              <a:rPr sz="1300">
-                <a:solidFill>
-                  <a:srgbClr val="F8FAFC"/>
-                </a:solidFill>
-              </a:rPr>
-              <a:t>• Audit expectations are getting stricter</a:t>
-            </a:r>
-          </a:p>
-        </p:txBody>
-      </p:sp>
-      <p:sp>
-        <p:nvSpPr>
-          <p:cNvPr id="11" name="TextBox 10"/>
-          <p:cNvSpPr txBox="1"/>
-          <p:nvPr/>
-        </p:nvSpPr>
-        <p:spPr>
-          <a:xfrm>
-            <a:off x="8778240" y="1371600"/>
-            <a:ext cx="2468880" cy="365760"/>
-          </a:xfrm>
-          <a:prstGeom prst="rect">
-            <a:avLst/>
-          </a:prstGeom>
-          <a:noFill/>
-        </p:spPr>
-        <p:txBody>
-          <a:bodyPr wrap="square">
-            <a:spAutoFit/>
-          </a:bodyPr>
-          <a:lstStyle/>
-          <a:p>
-            <a:pPr algn="l"/>
-            <a:r>
-              <a:rPr sz="1300" b="1" i="0">
-                <a:solidFill>
-                  <a:srgbClr val="22C55E"/>
-                </a:solidFill>
-              </a:rPr>
-              <a:t>SOC is too expensive</a:t>
-            </a:r>
-          </a:p>
-        </p:txBody>
-      </p:sp>
-      <p:sp>
-        <p:nvSpPr>
-          <p:cNvPr id="12" name="TextBox 11"/>
-          <p:cNvSpPr txBox="1"/>
-          <p:nvPr/>
-        </p:nvSpPr>
-        <p:spPr>
-          <a:xfrm>
-            <a:off x="8778240" y="1737360"/>
-            <a:ext cx="2468880" cy="3657600"/>
-          </a:xfrm>
-          <a:prstGeom prst="rect">
-            <a:avLst/>
-          </a:prstGeom>
-          <a:noFill/>
-        </p:spPr>
-        <p:txBody>
-          <a:bodyPr wrap="square">
-            <a:spAutoFit/>
-          </a:bodyPr>
-          <a:lstStyle/>
-          <a:p>
-            <a:pPr>
-              <a:spcBef>
-                <a:spcPts val="600"/>
-              </a:spcBef>
-            </a:pPr>
-            <a:r>
-              <a:rPr sz="1300">
-                <a:solidFill>
-                  <a:srgbClr val="F8FAFC"/>
-                </a:solidFill>
-              </a:rPr>
-              <a:t>• Full Security Operations Center is a RM 10k–30k/month commitment</a:t>
-            </a:r>
-          </a:p>
-          <a:p>
-            <a:pPr>
-              <a:spcBef>
-                <a:spcPts val="600"/>
-              </a:spcBef>
-            </a:pPr>
-            <a:r>
-              <a:rPr sz="1300">
-                <a:solidFill>
-                  <a:srgbClr val="F8FAFC"/>
-                </a:solidFill>
-              </a:rPr>
-              <a:t>• Most SMEs don't have the headcount or budget for it</a:t>
-            </a:r>
-          </a:p>
-          <a:p>
-            <a:pPr>
-              <a:spcBef>
-                <a:spcPts val="600"/>
-              </a:spcBef>
-            </a:pPr>
-            <a:r>
-              <a:rPr sz="1300">
-                <a:solidFill>
-                  <a:srgbClr val="F8FAFC"/>
-                </a:solidFill>
-              </a:rPr>
-              <a:t>• Hiring is slow and talent is scarce</a:t>
+              <a:t>PDPA + enterprise questionnaires
+= real pressure.</a:t>
             </a:r>
           </a:p>
         </p:txBody>
@@ -3942,8 +3874,8 @@
         </p:nvSpPr>
         <p:spPr>
           <a:xfrm>
-            <a:off x="548640" y="5120640"/>
-            <a:ext cx="11064240" cy="1188720"/>
+            <a:off x="548640" y="5394960"/>
+            <a:ext cx="11064240" cy="1097280"/>
           </a:xfrm>
           <a:prstGeom prst="rect">
             <a:avLst/>
@@ -3987,8 +3919,8 @@
         </p:nvSpPr>
         <p:spPr>
           <a:xfrm>
-            <a:off x="822960" y="5230368"/>
-            <a:ext cx="10515600" cy="1005840"/>
+            <a:off x="822960" y="5486400"/>
+            <a:ext cx="10515600" cy="411480"/>
           </a:xfrm>
           <a:prstGeom prst="rect">
             <a:avLst/>
@@ -4008,7 +3940,41 @@
                   <a:srgbClr val="FFFFFF"/>
                 </a:solidFill>
               </a:rPr>
-              <a:t>Most companies know they need better security operations — but not a heavyweight security program.</a:t>
+              <a:t>Most companies need better security operations —</a:t>
+            </a:r>
+          </a:p>
+        </p:txBody>
+      </p:sp>
+      <p:sp>
+        <p:nvSpPr>
+          <p:cNvPr id="15" name="TextBox 14"/>
+          <p:cNvSpPr txBox="1"/>
+          <p:nvPr/>
+        </p:nvSpPr>
+        <p:spPr>
+          <a:xfrm>
+            <a:off x="822960" y="5852160"/>
+            <a:ext cx="10515600" cy="411480"/>
+          </a:xfrm>
+          <a:prstGeom prst="rect">
+            <a:avLst/>
+          </a:prstGeom>
+          <a:noFill/>
+        </p:spPr>
+        <p:txBody>
+          <a:bodyPr wrap="square">
+            <a:spAutoFit/>
+          </a:bodyPr>
+          <a:lstStyle/>
+          <a:p>
+            <a:pPr algn="l"/>
+            <a:r>
+              <a:rPr sz="1600" b="1" i="0">
+                <a:solidFill>
+                  <a:srgbClr val="22C55E"/>
+                </a:solidFill>
+              </a:rPr>
+              <a:t>but not the cost and complexity of a full SOC.</a:t>
             </a:r>
           </a:p>
         </p:txBody>
@@ -4047,8 +4013,8 @@
         </p:nvSpPr>
         <p:spPr>
           <a:xfrm>
-            <a:off x="548640" y="228600"/>
-            <a:ext cx="10972800" cy="640080"/>
+            <a:off x="548640" y="256032"/>
+            <a:ext cx="10972800" cy="731520"/>
           </a:xfrm>
           <a:prstGeom prst="rect">
             <a:avLst/>
@@ -4063,7 +4029,7 @@
           <a:p>
             <a:pPr algn="l"/>
             <a:r>
-              <a:rPr sz="3000" b="1" i="0">
+              <a:rPr sz="3200" b="1" i="0">
                 <a:solidFill>
                   <a:srgbClr val="F8FAFC"/>
                 </a:solidFill>
@@ -4081,8 +4047,8 @@
         </p:nvSpPr>
         <p:spPr>
           <a:xfrm>
-            <a:off x="548640" y="749808"/>
-            <a:ext cx="10972800" cy="320040"/>
+            <a:off x="548640" y="868680"/>
+            <a:ext cx="10972800" cy="365760"/>
           </a:xfrm>
           <a:prstGeom prst="rect">
             <a:avLst/>
@@ -4099,7 +4065,7 @@
             <a:r>
               <a:rPr sz="1400" b="0" i="0">
                 <a:solidFill>
-                  <a:srgbClr val="CBD5E1"/>
+                  <a:srgbClr val="94A3B8"/>
                 </a:solidFill>
               </a:rPr>
               <a:t>The lean managed security layer for critical systems</a:t>
@@ -4115,7 +4081,7 @@
         </p:nvSpPr>
         <p:spPr>
           <a:xfrm>
-            <a:off x="548640" y="1078992"/>
+            <a:off x="548640" y="1207008"/>
             <a:ext cx="11064240" cy="38100"/>
           </a:xfrm>
           <a:prstGeom prst="rect">
@@ -4158,8 +4124,8 @@
         </p:nvSpPr>
         <p:spPr>
           <a:xfrm>
-            <a:off x="548640" y="1325880"/>
-            <a:ext cx="2194560" cy="347472"/>
+            <a:off x="548640" y="1417320"/>
+            <a:ext cx="2194560" cy="365760"/>
           </a:xfrm>
           <a:prstGeom prst="rect">
             <a:avLst/>
@@ -4186,7 +4152,7 @@
           </a:fontRef>
         </p:style>
         <p:txBody>
-          <a:bodyPr rtlCol="0" anchor="ctr" wrap="none"/>
+          <a:bodyPr rtlCol="0" anchor="ctr"/>
           <a:lstStyle/>
           <a:p>
             <a:pPr algn="ctr"/>
@@ -4209,8 +4175,8 @@
         </p:nvSpPr>
         <p:spPr>
           <a:xfrm>
-            <a:off x="2926080" y="1371600"/>
-            <a:ext cx="8686800" cy="365760"/>
+            <a:off x="2880360" y="1463040"/>
+            <a:ext cx="8869680" cy="365760"/>
           </a:xfrm>
           <a:prstGeom prst="rect">
             <a:avLst/>
@@ -4230,7 +4196,7 @@
                   <a:srgbClr val="F8FAFC"/>
                 </a:solidFill>
               </a:rPr>
-              <a:t>Linux / cloud environments monitored 24/7. Real alerts, not noise.</a:t>
+              <a:t>24/7 coverage for Linux / cloud. Real alerts, not noise.</a:t>
             </a:r>
           </a:p>
         </p:txBody>
@@ -4243,8 +4209,8 @@
         </p:nvSpPr>
         <p:spPr>
           <a:xfrm>
-            <a:off x="548640" y="2267712"/>
-            <a:ext cx="2194560" cy="347472"/>
+            <a:off x="548640" y="2313432"/>
+            <a:ext cx="2194560" cy="365760"/>
           </a:xfrm>
           <a:prstGeom prst="rect">
             <a:avLst/>
@@ -4271,7 +4237,7 @@
           </a:fontRef>
         </p:style>
         <p:txBody>
-          <a:bodyPr rtlCol="0" anchor="ctr" wrap="none"/>
+          <a:bodyPr rtlCol="0" anchor="ctr"/>
           <a:lstStyle/>
           <a:p>
             <a:pPr algn="ctr"/>
@@ -4294,8 +4260,8 @@
         </p:nvSpPr>
         <p:spPr>
           <a:xfrm>
-            <a:off x="2926080" y="2313432"/>
-            <a:ext cx="8686800" cy="365760"/>
+            <a:off x="2880360" y="2359152"/>
+            <a:ext cx="8869680" cy="365760"/>
           </a:xfrm>
           <a:prstGeom prst="rect">
             <a:avLst/>
@@ -4315,7 +4281,7 @@
                   <a:srgbClr val="F8FAFC"/>
                 </a:solidFill>
               </a:rPr>
-              <a:t>We filter the noise, prioritize real issues, and surface what matters.</a:t>
+              <a:t>We filter noise and surface what needs attention.</a:t>
             </a:r>
           </a:p>
         </p:txBody>
@@ -4329,7 +4295,7 @@
         <p:spPr>
           <a:xfrm>
             <a:off x="548640" y="3209544"/>
-            <a:ext cx="2194560" cy="347472"/>
+            <a:ext cx="2194560" cy="365760"/>
           </a:xfrm>
           <a:prstGeom prst="rect">
             <a:avLst/>
@@ -4356,7 +4322,7 @@
           </a:fontRef>
         </p:style>
         <p:txBody>
-          <a:bodyPr rtlCol="0" anchor="ctr" wrap="none"/>
+          <a:bodyPr rtlCol="0" anchor="ctr"/>
           <a:lstStyle/>
           <a:p>
             <a:pPr algn="ctr"/>
@@ -4379,8 +4345,8 @@
         </p:nvSpPr>
         <p:spPr>
           <a:xfrm>
-            <a:off x="2926080" y="3255264"/>
-            <a:ext cx="8686800" cy="365760"/>
+            <a:off x="2880360" y="3255264"/>
+            <a:ext cx="8869680" cy="365760"/>
           </a:xfrm>
           <a:prstGeom prst="rect">
             <a:avLst/>
@@ -4400,7 +4366,7 @@
                   <a:srgbClr val="F8FAFC"/>
                 </a:solidFill>
               </a:rPr>
-              <a:t>Practical CIS-aligned controls applied on approved systems.</a:t>
+              <a:t>Practical CIS-aligned controls on approved systems.</a:t>
             </a:r>
           </a:p>
         </p:txBody>
@@ -4413,8 +4379,8 @@
         </p:nvSpPr>
         <p:spPr>
           <a:xfrm>
-            <a:off x="548640" y="4151376"/>
-            <a:ext cx="2194560" cy="347472"/>
+            <a:off x="548640" y="4105656"/>
+            <a:ext cx="2194560" cy="365760"/>
           </a:xfrm>
           <a:prstGeom prst="rect">
             <a:avLst/>
@@ -4441,7 +4407,7 @@
           </a:fontRef>
         </p:style>
         <p:txBody>
-          <a:bodyPr rtlCol="0" anchor="ctr" wrap="none"/>
+          <a:bodyPr rtlCol="0" anchor="ctr"/>
           <a:lstStyle/>
           <a:p>
             <a:pPr algn="ctr"/>
@@ -4464,8 +4430,8 @@
         </p:nvSpPr>
         <p:spPr>
           <a:xfrm>
-            <a:off x="2926080" y="4197096"/>
-            <a:ext cx="8686800" cy="365760"/>
+            <a:off x="2880360" y="4151376"/>
+            <a:ext cx="8869680" cy="365760"/>
           </a:xfrm>
           <a:prstGeom prst="rect">
             <a:avLst/>
@@ -4485,7 +4451,7 @@
                   <a:srgbClr val="F8FAFC"/>
                 </a:solidFill>
               </a:rPr>
-              <a:t>Management-ready output — findings, risk trends, recommended next steps.</a:t>
+              <a:t>Management-ready — findings, risk trends, next steps.</a:t>
             </a:r>
           </a:p>
         </p:txBody>
@@ -4498,8 +4464,8 @@
         </p:nvSpPr>
         <p:spPr>
           <a:xfrm>
-            <a:off x="548640" y="5093208"/>
-            <a:ext cx="2194560" cy="347472"/>
+            <a:off x="548640" y="5001768"/>
+            <a:ext cx="2194560" cy="365760"/>
           </a:xfrm>
           <a:prstGeom prst="rect">
             <a:avLst/>
@@ -4526,7 +4492,7 @@
           </a:fontRef>
         </p:style>
         <p:txBody>
-          <a:bodyPr rtlCol="0" anchor="ctr" wrap="none"/>
+          <a:bodyPr rtlCol="0" anchor="ctr"/>
           <a:lstStyle/>
           <a:p>
             <a:pPr algn="ctr"/>
@@ -4549,8 +4515,8 @@
         </p:nvSpPr>
         <p:spPr>
           <a:xfrm>
-            <a:off x="2926080" y="5138928"/>
-            <a:ext cx="8686800" cy="365760"/>
+            <a:off x="2880360" y="5047488"/>
+            <a:ext cx="8869680" cy="365760"/>
           </a:xfrm>
           <a:prstGeom prst="rect">
             <a:avLst/>
@@ -4570,7 +4536,7 @@
                   <a:srgbClr val="F8FAFC"/>
                 </a:solidFill>
               </a:rPr>
-              <a:t>30-day limited-scope pilot designed to prove value without overcommitment.</a:t>
+              <a:t>30-day limited-scope pilot. Prove value, no overcommitment.</a:t>
             </a:r>
           </a:p>
         </p:txBody>
@@ -4583,8 +4549,8 @@
         </p:nvSpPr>
         <p:spPr>
           <a:xfrm>
-            <a:off x="548640" y="6035040"/>
-            <a:ext cx="11064240" cy="640080"/>
+            <a:off x="548640" y="5989320"/>
+            <a:ext cx="11064240" cy="594360"/>
           </a:xfrm>
           <a:prstGeom prst="rect">
             <a:avLst/>
@@ -4628,8 +4594,8 @@
         </p:nvSpPr>
         <p:spPr>
           <a:xfrm>
-            <a:off x="822960" y="6108192"/>
-            <a:ext cx="10515600" cy="502920"/>
+            <a:off x="777240" y="6053328"/>
+            <a:ext cx="10515600" cy="457200"/>
           </a:xfrm>
           <a:prstGeom prst="rect">
             <a:avLst/>
@@ -4649,7 +4615,7 @@
                   <a:srgbClr val="22C55E"/>
                 </a:solidFill>
               </a:rPr>
-              <a:t>Enterprise-style security visibility and hardening — without hiring a SOC.</a:t>
+              <a:t>Enterprise security visibility and hardening — without hiring a SOC.</a:t>
             </a:r>
           </a:p>
         </p:txBody>
@@ -4688,8 +4654,8 @@
         </p:nvSpPr>
         <p:spPr>
           <a:xfrm>
-            <a:off x="548640" y="228600"/>
-            <a:ext cx="10972800" cy="640080"/>
+            <a:off x="548640" y="256032"/>
+            <a:ext cx="10972800" cy="731520"/>
           </a:xfrm>
           <a:prstGeom prst="rect">
             <a:avLst/>
@@ -4704,7 +4670,7 @@
           <a:p>
             <a:pPr algn="l"/>
             <a:r>
-              <a:rPr sz="3000" b="1" i="0">
+              <a:rPr sz="3200" b="1" i="0">
                 <a:solidFill>
                   <a:srgbClr val="F8FAFC"/>
                 </a:solidFill>
@@ -4722,8 +4688,8 @@
         </p:nvSpPr>
         <p:spPr>
           <a:xfrm>
-            <a:off x="548640" y="749808"/>
-            <a:ext cx="10972800" cy="320040"/>
+            <a:off x="548640" y="868680"/>
+            <a:ext cx="10972800" cy="365760"/>
           </a:xfrm>
           <a:prstGeom prst="rect">
             <a:avLst/>
@@ -4740,10 +4706,10 @@
             <a:r>
               <a:rPr sz="1400" b="0" i="0">
                 <a:solidFill>
-                  <a:srgbClr val="CBD5E1"/>
-                </a:solidFill>
-              </a:rPr>
-              <a:t>Ideal customer profile — intentionally focused</a:t>
+                  <a:srgbClr val="94A3B8"/>
+                </a:solidFill>
+              </a:rPr>
+              <a:t>We target deliberately — where security pressure is real and teams are lean</a:t>
             </a:r>
           </a:p>
         </p:txBody>
@@ -4756,7 +4722,7 @@
         </p:nvSpPr>
         <p:spPr>
           <a:xfrm>
-            <a:off x="548640" y="1078992"/>
+            <a:off x="548640" y="1207008"/>
             <a:ext cx="11064240" cy="38100"/>
           </a:xfrm>
           <a:prstGeom prst="rect">
@@ -4799,8 +4765,8 @@
         </p:nvSpPr>
         <p:spPr>
           <a:xfrm>
-            <a:off x="548640" y="1280160"/>
-            <a:ext cx="5394960" cy="4572000"/>
+            <a:off x="548640" y="1417320"/>
+            <a:ext cx="5394960" cy="4389120"/>
           </a:xfrm>
           <a:prstGeom prst="rect">
             <a:avLst/>
@@ -4844,7 +4810,7 @@
         </p:nvSpPr>
         <p:spPr>
           <a:xfrm>
-            <a:off x="777240" y="1417320"/>
+            <a:off x="777240" y="1536192"/>
             <a:ext cx="4937760" cy="411480"/>
           </a:xfrm>
           <a:prstGeom prst="rect">
@@ -4860,7 +4826,7 @@
           <a:p>
             <a:pPr algn="l"/>
             <a:r>
-              <a:rPr sz="1600" b="1" i="0">
+              <a:rPr sz="1700" b="1" i="0">
                 <a:solidFill>
                   <a:srgbClr val="22C55E"/>
                 </a:solidFill>
@@ -4878,8 +4844,8 @@
         </p:nvSpPr>
         <p:spPr>
           <a:xfrm>
-            <a:off x="777240" y="1874519"/>
-            <a:ext cx="4937760" cy="3657600"/>
+            <a:off x="777240" y="1993392"/>
+            <a:ext cx="4937760" cy="3474720"/>
           </a:xfrm>
           <a:prstGeom prst="rect">
             <a:avLst/>
@@ -4948,7 +4914,7 @@
                   <a:srgbClr val="F8FAFC"/>
                 </a:solidFill>
               </a:rPr>
-              <a:t>• Enterprise security questionnaires or PDPA compliance pressure</a:t>
+              <a:t>• PDPA compliance or enterprise security questionnaires</a:t>
             </a:r>
           </a:p>
           <a:p>
@@ -4966,21 +4932,6 @@
               <a:t>• Lean IT teams — no internal SOC</a:t>
             </a:r>
           </a:p>
-          <a:p>
-            <a:pPr>
-              <a:spcBef>
-                <a:spcPts val="800"/>
-              </a:spcBef>
-            </a:pPr>
-            <a:r>
-              <a:rPr sz="1400">
-                <a:solidFill>
-                  <a:srgbClr val="F8FAFC"/>
-                </a:solidFill>
-              </a:rPr>
-              <a:t>• Seeking practical security improvement, not compliance theatre</a:t>
-            </a:r>
-          </a:p>
         </p:txBody>
       </p:sp>
       <p:sp>
@@ -4991,8 +4942,8 @@
         </p:nvSpPr>
         <p:spPr>
           <a:xfrm>
-            <a:off x="6217920" y="1280160"/>
-            <a:ext cx="5394960" cy="4572000"/>
+            <a:off x="6217920" y="1417320"/>
+            <a:ext cx="5394960" cy="4389120"/>
           </a:xfrm>
           <a:prstGeom prst="rect">
             <a:avLst/>
@@ -5036,7 +4987,7 @@
         </p:nvSpPr>
         <p:spPr>
           <a:xfrm>
-            <a:off x="6446520" y="1417320"/>
+            <a:off x="6446520" y="1536192"/>
             <a:ext cx="4937760" cy="411480"/>
           </a:xfrm>
           <a:prstGeom prst="rect">
@@ -5052,7 +5003,7 @@
           <a:p>
             <a:pPr algn="l"/>
             <a:r>
-              <a:rPr sz="1600" b="1" i="0">
+              <a:rPr sz="1700" b="1" i="0">
                 <a:solidFill>
                   <a:srgbClr val="FC8181"/>
                 </a:solidFill>
@@ -5070,8 +5021,8 @@
         </p:nvSpPr>
         <p:spPr>
           <a:xfrm>
-            <a:off x="6446520" y="1874519"/>
-            <a:ext cx="4937760" cy="3200400"/>
+            <a:off x="6446520" y="1993392"/>
+            <a:ext cx="4937760" cy="2560320"/>
           </a:xfrm>
           <a:prstGeom prst="rect">
             <a:avLst/>
@@ -5092,7 +5043,7 @@
             <a:r>
               <a:rPr sz="1400">
                 <a:solidFill>
-                  <a:srgbClr val="CBD5E1"/>
+                  <a:srgbClr val="94A3B8"/>
                 </a:solidFill>
               </a:rPr>
               <a:t>• Very large enterprises needing broad coverage</a:t>
@@ -5107,7 +5058,7 @@
             <a:r>
               <a:rPr sz="1400">
                 <a:solidFill>
-                  <a:srgbClr val="CBD5E1"/>
+                  <a:srgbClr val="94A3B8"/>
                 </a:solidFill>
               </a:rPr>
               <a:t>• Banks or regulated financial institutions requiring formal SOC</a:t>
@@ -5122,25 +5073,10 @@
             <a:r>
               <a:rPr sz="1400">
                 <a:solidFill>
-                  <a:srgbClr val="CBD5E1"/>
-                </a:solidFill>
-              </a:rPr>
-              <a:t>• Clients expecting extensive custom consulting from day one</a:t>
-            </a:r>
-          </a:p>
-          <a:p>
-            <a:pPr>
-              <a:spcBef>
-                <a:spcPts val="800"/>
-              </a:spcBef>
-            </a:pPr>
-            <a:r>
-              <a:rPr sz="1400">
-                <a:solidFill>
-                  <a:srgbClr val="CBD5E1"/>
-                </a:solidFill>
-              </a:rPr>
-              <a:t>• Environments with no existing IT infrastructure to harden</a:t>
+                  <a:srgbClr val="94A3B8"/>
+                </a:solidFill>
+              </a:rPr>
+              <a:t>• Expecting extensive custom consulting from day one</a:t>
             </a:r>
           </a:p>
         </p:txBody>
@@ -5153,7 +5089,7 @@
         </p:nvSpPr>
         <p:spPr>
           <a:xfrm>
-            <a:off x="548640" y="6080760"/>
+            <a:off x="548640" y="5989320"/>
             <a:ext cx="11064240" cy="502920"/>
           </a:xfrm>
           <a:prstGeom prst="rect">
@@ -5171,10 +5107,10 @@
             <a:r>
               <a:rPr sz="1300" b="0" i="1">
                 <a:solidFill>
-                  <a:srgbClr val="CBD5E1"/>
-                </a:solidFill>
-              </a:rPr>
-              <a:t>We win where security pressure is real but internal security operations are still lean.</a:t>
+                  <a:srgbClr val="94A3B8"/>
+                </a:solidFill>
+              </a:rPr>
+              <a:t>We win where security pressure is real but security ops are still lean.</a:t>
             </a:r>
           </a:p>
         </p:txBody>
@@ -5213,8 +5149,8 @@
         </p:nvSpPr>
         <p:spPr>
           <a:xfrm>
-            <a:off x="548640" y="228600"/>
-            <a:ext cx="10972800" cy="640080"/>
+            <a:off x="548640" y="256032"/>
+            <a:ext cx="10972800" cy="731520"/>
           </a:xfrm>
           <a:prstGeom prst="rect">
             <a:avLst/>
@@ -5229,12 +5165,12 @@
           <a:p>
             <a:pPr algn="l"/>
             <a:r>
-              <a:rPr sz="3000" b="1" i="0">
+              <a:rPr sz="3200" b="1" i="0">
                 <a:solidFill>
                   <a:srgbClr val="F8FAFC"/>
                 </a:solidFill>
               </a:rPr>
-              <a:t>How It Works in Practice</a:t>
+              <a:t>How It Works</a:t>
             </a:r>
           </a:p>
         </p:txBody>
@@ -5247,8 +5183,8 @@
         </p:nvSpPr>
         <p:spPr>
           <a:xfrm>
-            <a:off x="548640" y="749808"/>
-            <a:ext cx="10972800" cy="320040"/>
+            <a:off x="548640" y="868680"/>
+            <a:ext cx="10972800" cy="365760"/>
           </a:xfrm>
           <a:prstGeom prst="rect">
             <a:avLst/>
@@ -5265,10 +5201,10 @@
             <a:r>
               <a:rPr sz="1400" b="0" i="0">
                 <a:solidFill>
-                  <a:srgbClr val="CBD5E1"/>
-                </a:solidFill>
-              </a:rPr>
-              <a:t>Four steps to operational security clarity — small scope, clear signal</a:t>
+                  <a:srgbClr val="94A3B8"/>
+                </a:solidFill>
+              </a:rPr>
+              <a:t>Small scope. Clear signal. Practical output.</a:t>
             </a:r>
           </a:p>
         </p:txBody>
@@ -5281,7 +5217,7 @@
         </p:nvSpPr>
         <p:spPr>
           <a:xfrm>
-            <a:off x="548640" y="1078992"/>
+            <a:off x="548640" y="1207008"/>
             <a:ext cx="11064240" cy="38100"/>
           </a:xfrm>
           <a:prstGeom prst="rect">
@@ -5324,8 +5260,8 @@
         </p:nvSpPr>
         <p:spPr>
           <a:xfrm>
-            <a:off x="676656" y="1463040"/>
-            <a:ext cx="2468880" cy="502920"/>
+            <a:off x="544068" y="1508760"/>
+            <a:ext cx="2514600" cy="502920"/>
           </a:xfrm>
           <a:prstGeom prst="rect">
             <a:avLst/>
@@ -5352,12 +5288,12 @@
           </a:fontRef>
         </p:style>
         <p:txBody>
-          <a:bodyPr rtlCol="0" anchor="ctr" wrap="none"/>
+          <a:bodyPr rtlCol="0" anchor="ctr"/>
           <a:lstStyle/>
           <a:p>
             <a:pPr algn="ctr"/>
             <a:r>
-              <a:rPr sz="2000" b="1">
+              <a:rPr sz="2200" b="1">
                 <a:solidFill>
                   <a:srgbClr val="FFFFFF"/>
                 </a:solidFill>
@@ -5375,8 +5311,8 @@
         </p:nvSpPr>
         <p:spPr>
           <a:xfrm>
-            <a:off x="676656" y="2057400"/>
-            <a:ext cx="2468880" cy="3840480"/>
+            <a:off x="544068" y="2103120"/>
+            <a:ext cx="2514600" cy="3108960"/>
           </a:xfrm>
           <a:prstGeom prst="rect">
             <a:avLst/>
@@ -5420,8 +5356,8 @@
         </p:nvSpPr>
         <p:spPr>
           <a:xfrm>
-            <a:off x="813816" y="2194560"/>
-            <a:ext cx="2194560" cy="457200"/>
+            <a:off x="681228" y="2240280"/>
+            <a:ext cx="2240280" cy="457200"/>
           </a:xfrm>
           <a:prstGeom prst="rect">
             <a:avLst/>
@@ -5454,8 +5390,8 @@
         </p:nvSpPr>
         <p:spPr>
           <a:xfrm>
-            <a:off x="813816" y="2743200"/>
-            <a:ext cx="2194560" cy="2926080"/>
+            <a:off x="681228" y="2788920"/>
+            <a:ext cx="2240280" cy="2194560"/>
           </a:xfrm>
           <a:prstGeom prst="rect">
             <a:avLst/>
@@ -5475,7 +5411,7 @@
                   <a:srgbClr val="F8FAFC"/>
                 </a:solidFill>
               </a:rPr>
-              <a:t>Deploy monitoring on a small, agreed scope of critical systems. Define what's in scope and what's not.</a:t>
+              <a:t>Deploy monitoring on agreed critical systems. Define scope.</a:t>
             </a:r>
           </a:p>
         </p:txBody>
@@ -5488,8 +5424,8 @@
         </p:nvSpPr>
         <p:spPr>
           <a:xfrm>
-            <a:off x="3465576" y="1463040"/>
-            <a:ext cx="2468880" cy="502920"/>
+            <a:off x="3406140" y="1508760"/>
+            <a:ext cx="2514600" cy="502920"/>
           </a:xfrm>
           <a:prstGeom prst="rect">
             <a:avLst/>
@@ -5516,12 +5452,12 @@
           </a:fontRef>
         </p:style>
         <p:txBody>
-          <a:bodyPr rtlCol="0" anchor="ctr" wrap="none"/>
+          <a:bodyPr rtlCol="0" anchor="ctr"/>
           <a:lstStyle/>
           <a:p>
             <a:pPr algn="ctr"/>
             <a:r>
-              <a:rPr sz="2000" b="1">
+              <a:rPr sz="2200" b="1">
                 <a:solidFill>
                   <a:srgbClr val="FFFFFF"/>
                 </a:solidFill>
@@ -5539,8 +5475,8 @@
         </p:nvSpPr>
         <p:spPr>
           <a:xfrm>
-            <a:off x="3465576" y="2057400"/>
-            <a:ext cx="2468880" cy="3840480"/>
+            <a:off x="3406140" y="2103120"/>
+            <a:ext cx="2514600" cy="3108960"/>
           </a:xfrm>
           <a:prstGeom prst="rect">
             <a:avLst/>
@@ -5584,8 +5520,8 @@
         </p:nvSpPr>
         <p:spPr>
           <a:xfrm>
-            <a:off x="3602736" y="2194560"/>
-            <a:ext cx="2194560" cy="457200"/>
+            <a:off x="3543300" y="2240280"/>
+            <a:ext cx="2240280" cy="457200"/>
           </a:xfrm>
           <a:prstGeom prst="rect">
             <a:avLst/>
@@ -5618,8 +5554,8 @@
         </p:nvSpPr>
         <p:spPr>
           <a:xfrm>
-            <a:off x="3602736" y="2743200"/>
-            <a:ext cx="2194560" cy="2926080"/>
+            <a:off x="3543300" y="2788920"/>
+            <a:ext cx="2240280" cy="2194560"/>
           </a:xfrm>
           <a:prstGeom prst="rect">
             <a:avLst/>
@@ -5639,7 +5575,7 @@
                   <a:srgbClr val="F8FAFC"/>
                 </a:solidFill>
               </a:rPr>
-              <a:t>Filter noisy alerts, prioritize meaningful issues. Real threats surface — noise is triage by us.</a:t>
+              <a:t>Filter noise. Prioritize real issues. Surface what matters.</a:t>
             </a:r>
           </a:p>
         </p:txBody>
@@ -5652,8 +5588,8 @@
         </p:nvSpPr>
         <p:spPr>
           <a:xfrm>
-            <a:off x="6254496" y="1463040"/>
-            <a:ext cx="2468880" cy="502920"/>
+            <a:off x="6268212" y="1508760"/>
+            <a:ext cx="2514600" cy="502920"/>
           </a:xfrm>
           <a:prstGeom prst="rect">
             <a:avLst/>
@@ -5680,12 +5616,12 @@
           </a:fontRef>
         </p:style>
         <p:txBody>
-          <a:bodyPr rtlCol="0" anchor="ctr" wrap="none"/>
+          <a:bodyPr rtlCol="0" anchor="ctr"/>
           <a:lstStyle/>
           <a:p>
             <a:pPr algn="ctr"/>
             <a:r>
-              <a:rPr sz="2000" b="1">
+              <a:rPr sz="2200" b="1">
                 <a:solidFill>
                   <a:srgbClr val="FFFFFF"/>
                 </a:solidFill>
@@ -5703,8 +5639,8 @@
         </p:nvSpPr>
         <p:spPr>
           <a:xfrm>
-            <a:off x="6254496" y="2057400"/>
-            <a:ext cx="2468880" cy="3840480"/>
+            <a:off x="6268212" y="2103120"/>
+            <a:ext cx="2514600" cy="3108960"/>
           </a:xfrm>
           <a:prstGeom prst="rect">
             <a:avLst/>
@@ -5748,8 +5684,8 @@
         </p:nvSpPr>
         <p:spPr>
           <a:xfrm>
-            <a:off x="6391656" y="2194560"/>
-            <a:ext cx="2194560" cy="457200"/>
+            <a:off x="6405372" y="2240280"/>
+            <a:ext cx="2240280" cy="457200"/>
           </a:xfrm>
           <a:prstGeom prst="rect">
             <a:avLst/>
@@ -5782,8 +5718,8 @@
         </p:nvSpPr>
         <p:spPr>
           <a:xfrm>
-            <a:off x="6391656" y="2743200"/>
-            <a:ext cx="2194560" cy="2926080"/>
+            <a:off x="6405372" y="2788920"/>
+            <a:ext cx="2240280" cy="2194560"/>
           </a:xfrm>
           <a:prstGeom prst="rect">
             <a:avLst/>
@@ -5803,7 +5739,7 @@
                   <a:srgbClr val="F8FAFC"/>
                 </a:solidFill>
               </a:rPr>
-              <a:t>Apply practical security improvements on approved systems. CIS-aligned controls, not theoretical hardening.</a:t>
+              <a:t>Apply practical CIS-aligned controls on approved systems.</a:t>
             </a:r>
           </a:p>
         </p:txBody>
@@ -5816,8 +5752,8 @@
         </p:nvSpPr>
         <p:spPr>
           <a:xfrm>
-            <a:off x="9043416" y="1463040"/>
-            <a:ext cx="2468880" cy="502920"/>
+            <a:off x="9130284" y="1508760"/>
+            <a:ext cx="2514600" cy="502920"/>
           </a:xfrm>
           <a:prstGeom prst="rect">
             <a:avLst/>
@@ -5844,12 +5780,12 @@
           </a:fontRef>
         </p:style>
         <p:txBody>
-          <a:bodyPr rtlCol="0" anchor="ctr" wrap="none"/>
+          <a:bodyPr rtlCol="0" anchor="ctr"/>
           <a:lstStyle/>
           <a:p>
             <a:pPr algn="ctr"/>
             <a:r>
-              <a:rPr sz="2000" b="1">
+              <a:rPr sz="2200" b="1">
                 <a:solidFill>
                   <a:srgbClr val="FFFFFF"/>
                 </a:solidFill>
@@ -5867,8 +5803,8 @@
         </p:nvSpPr>
         <p:spPr>
           <a:xfrm>
-            <a:off x="9043416" y="2057400"/>
-            <a:ext cx="2468880" cy="3840480"/>
+            <a:off x="9130284" y="2103120"/>
+            <a:ext cx="2514600" cy="3108960"/>
           </a:xfrm>
           <a:prstGeom prst="rect">
             <a:avLst/>
@@ -5912,8 +5848,8 @@
         </p:nvSpPr>
         <p:spPr>
           <a:xfrm>
-            <a:off x="9180576" y="2194560"/>
-            <a:ext cx="2194560" cy="457200"/>
+            <a:off x="9267444" y="2240280"/>
+            <a:ext cx="2240280" cy="457200"/>
           </a:xfrm>
           <a:prstGeom prst="rect">
             <a:avLst/>
@@ -5946,8 +5882,8 @@
         </p:nvSpPr>
         <p:spPr>
           <a:xfrm>
-            <a:off x="9180576" y="2743200"/>
-            <a:ext cx="2194560" cy="2926080"/>
+            <a:off x="9267444" y="2788920"/>
+            <a:ext cx="2240280" cy="2194560"/>
           </a:xfrm>
           <a:prstGeom prst="rect">
             <a:avLst/>
@@ -5967,7 +5903,41 @@
                   <a:srgbClr val="F8FAFC"/>
                 </a:solidFill>
               </a:rPr>
-              <a:t>Clear findings, risk trends, recommended next actions. Management-ready output every month.</a:t>
+              <a:t>Clear findings, risk trends, recommended next steps monthly.</a:t>
+            </a:r>
+          </a:p>
+        </p:txBody>
+      </p:sp>
+      <p:sp>
+        <p:nvSpPr>
+          <p:cNvPr id="21" name="TextBox 20"/>
+          <p:cNvSpPr txBox="1"/>
+          <p:nvPr/>
+        </p:nvSpPr>
+        <p:spPr>
+          <a:xfrm>
+            <a:off x="548640" y="5623560"/>
+            <a:ext cx="11064240" cy="457200"/>
+          </a:xfrm>
+          <a:prstGeom prst="rect">
+            <a:avLst/>
+          </a:prstGeom>
+          <a:noFill/>
+        </p:spPr>
+        <p:txBody>
+          <a:bodyPr wrap="square">
+            <a:spAutoFit/>
+          </a:bodyPr>
+          <a:lstStyle/>
+          <a:p>
+            <a:pPr algn="ctr"/>
+            <a:r>
+              <a:rPr sz="1300" b="0" i="1">
+                <a:solidFill>
+                  <a:srgbClr val="94A3B8"/>
+                </a:solidFill>
+              </a:rPr>
+              <a:t>Small scope. Clear signal. Practical improvements. Useful reporting.</a:t>
             </a:r>
           </a:p>
         </p:txBody>
@@ -6006,8 +5976,8 @@
         </p:nvSpPr>
         <p:spPr>
           <a:xfrm>
-            <a:off x="548640" y="228600"/>
-            <a:ext cx="10972800" cy="640080"/>
+            <a:off x="548640" y="256032"/>
+            <a:ext cx="10972800" cy="731520"/>
           </a:xfrm>
           <a:prstGeom prst="rect">
             <a:avLst/>
@@ -6022,12 +5992,12 @@
           <a:p>
             <a:pPr algn="l"/>
             <a:r>
-              <a:rPr sz="3000" b="1" i="0">
+              <a:rPr sz="3200" b="1" i="0">
                 <a:solidFill>
                   <a:srgbClr val="F8FAFC"/>
                 </a:solidFill>
               </a:rPr>
-              <a:t>What We've Already Proven</a:t>
+              <a:t>What We've Proven</a:t>
             </a:r>
           </a:p>
         </p:txBody>
@@ -6040,8 +6010,8 @@
         </p:nvSpPr>
         <p:spPr>
           <a:xfrm>
-            <a:off x="548640" y="749808"/>
-            <a:ext cx="10972800" cy="320040"/>
+            <a:off x="548640" y="868680"/>
+            <a:ext cx="10972800" cy="365760"/>
           </a:xfrm>
           <a:prstGeom prst="rect">
             <a:avLst/>
@@ -6058,10 +6028,10 @@
             <a:r>
               <a:rPr sz="1400" b="0" i="0">
                 <a:solidFill>
-                  <a:srgbClr val="CBD5E1"/>
-                </a:solidFill>
-              </a:rPr>
-              <a:t>Wazuh-based MVP demo — real findings, real hardening evidence</a:t>
+                  <a:srgbClr val="94A3B8"/>
+                </a:solidFill>
+              </a:rPr>
+              <a:t>Real findings from our internal MVP demo</a:t>
             </a:r>
           </a:p>
         </p:txBody>
@@ -6074,7 +6044,7 @@
         </p:nvSpPr>
         <p:spPr>
           <a:xfrm>
-            <a:off x="548640" y="1078992"/>
+            <a:off x="548640" y="1207008"/>
             <a:ext cx="11064240" cy="38100"/>
           </a:xfrm>
           <a:prstGeom prst="rect">
@@ -6117,8 +6087,8 @@
         </p:nvSpPr>
         <p:spPr>
           <a:xfrm>
-            <a:off x="539496" y="1463040"/>
-            <a:ext cx="2468880" cy="914400"/>
+            <a:off x="425196" y="1508760"/>
+            <a:ext cx="2560320" cy="868680"/>
           </a:xfrm>
           <a:prstGeom prst="rect">
             <a:avLst/>
@@ -6145,12 +6115,12 @@
           </a:fontRef>
         </p:style>
         <p:txBody>
-          <a:bodyPr rtlCol="0" anchor="ctr" wrap="none"/>
+          <a:bodyPr rtlCol="0" anchor="ctr"/>
           <a:lstStyle/>
           <a:p>
             <a:pPr algn="ctr"/>
             <a:r>
-              <a:rPr sz="3600" b="1">
+              <a:rPr sz="3800" b="1">
                 <a:solidFill>
                   <a:srgbClr val="FFFFFF"/>
                 </a:solidFill>
@@ -6168,8 +6138,8 @@
         </p:nvSpPr>
         <p:spPr>
           <a:xfrm>
-            <a:off x="539496" y="2514600"/>
-            <a:ext cx="2468880" cy="731520"/>
+            <a:off x="425196" y="2514600"/>
+            <a:ext cx="2560320" cy="685800"/>
           </a:xfrm>
           <a:prstGeom prst="rect">
             <a:avLst/>
@@ -6186,11 +6156,11 @@
             <a:r>
               <a:rPr sz="1300" b="0" i="0">
                 <a:solidFill>
-                  <a:srgbClr val="CBD5E1"/>
+                  <a:srgbClr val="94A3B8"/>
                 </a:solidFill>
               </a:rPr>
               <a:t>Active agents
-enrolled &amp; monitoring</a:t>
+monitoring</a:t>
             </a:r>
           </a:p>
         </p:txBody>
@@ -6203,8 +6173,8 @@
         </p:nvSpPr>
         <p:spPr>
           <a:xfrm>
-            <a:off x="3419856" y="1463040"/>
-            <a:ext cx="2468880" cy="914400"/>
+            <a:off x="3351276" y="1508760"/>
+            <a:ext cx="2560320" cy="868680"/>
           </a:xfrm>
           <a:prstGeom prst="rect">
             <a:avLst/>
@@ -6231,12 +6201,12 @@
           </a:fontRef>
         </p:style>
         <p:txBody>
-          <a:bodyPr rtlCol="0" anchor="ctr" wrap="none"/>
+          <a:bodyPr rtlCol="0" anchor="ctr"/>
           <a:lstStyle/>
           <a:p>
             <a:pPr algn="ctr"/>
             <a:r>
-              <a:rPr sz="3600" b="1">
+              <a:rPr sz="3800" b="1">
                 <a:solidFill>
                   <a:srgbClr val="FFFFFF"/>
                 </a:solidFill>
@@ -6254,8 +6224,8 @@
         </p:nvSpPr>
         <p:spPr>
           <a:xfrm>
-            <a:off x="3419856" y="2514600"/>
-            <a:ext cx="2468880" cy="731520"/>
+            <a:off x="3351276" y="2514600"/>
+            <a:ext cx="2560320" cy="685800"/>
           </a:xfrm>
           <a:prstGeom prst="rect">
             <a:avLst/>
@@ -6272,11 +6242,11 @@
             <a:r>
               <a:rPr sz="1300" b="0" i="0">
                 <a:solidFill>
-                  <a:srgbClr val="CBD5E1"/>
-                </a:solidFill>
-              </a:rPr>
-              <a:t>Security events
-captured in 24h</a:t>
+                  <a:srgbClr val="94A3B8"/>
+                </a:solidFill>
+              </a:rPr>
+              <a:t>Events captured
+in 24 hrs</a:t>
             </a:r>
           </a:p>
         </p:txBody>
@@ -6289,8 +6259,8 @@
         </p:nvSpPr>
         <p:spPr>
           <a:xfrm>
-            <a:off x="6300216" y="1463040"/>
-            <a:ext cx="2468880" cy="914400"/>
+            <a:off x="6277356" y="1508760"/>
+            <a:ext cx="2560320" cy="868680"/>
           </a:xfrm>
           <a:prstGeom prst="rect">
             <a:avLst/>
@@ -6317,12 +6287,12 @@
           </a:fontRef>
         </p:style>
         <p:txBody>
-          <a:bodyPr rtlCol="0" anchor="ctr" wrap="none"/>
+          <a:bodyPr rtlCol="0" anchor="ctr"/>
           <a:lstStyle/>
           <a:p>
             <a:pPr algn="ctr"/>
             <a:r>
-              <a:rPr sz="3600" b="1">
+              <a:rPr sz="3800" b="1">
                 <a:solidFill>
                   <a:srgbClr val="FFFFFF"/>
                 </a:solidFill>
@@ -6340,8 +6310,8 @@
         </p:nvSpPr>
         <p:spPr>
           <a:xfrm>
-            <a:off x="6300216" y="2514600"/>
-            <a:ext cx="2468880" cy="731520"/>
+            <a:off x="6277356" y="2514600"/>
+            <a:ext cx="2560320" cy="685800"/>
           </a:xfrm>
           <a:prstGeom prst="rect">
             <a:avLst/>
@@ -6358,11 +6328,11 @@
             <a:r>
               <a:rPr sz="1300" b="0" i="0">
                 <a:solidFill>
-                  <a:srgbClr val="CBD5E1"/>
+                  <a:srgbClr val="94A3B8"/>
                 </a:solidFill>
               </a:rPr>
               <a:t>CIS benchmark
-checks executed</a:t>
+checks run</a:t>
             </a:r>
           </a:p>
         </p:txBody>
@@ -6375,8 +6345,8 @@
         </p:nvSpPr>
         <p:spPr>
           <a:xfrm>
-            <a:off x="9180576" y="1463040"/>
-            <a:ext cx="2468880" cy="914400"/>
+            <a:off x="9203436" y="1508760"/>
+            <a:ext cx="2560320" cy="868680"/>
           </a:xfrm>
           <a:prstGeom prst="rect">
             <a:avLst/>
@@ -6403,12 +6373,12 @@
           </a:fontRef>
         </p:style>
         <p:txBody>
-          <a:bodyPr rtlCol="0" anchor="ctr" wrap="none"/>
+          <a:bodyPr rtlCol="0" anchor="ctr"/>
           <a:lstStyle/>
           <a:p>
             <a:pPr algn="ctr"/>
             <a:r>
-              <a:rPr sz="3600" b="1">
+              <a:rPr sz="3800" b="1">
                 <a:solidFill>
                   <a:srgbClr val="FFFFFF"/>
                 </a:solidFill>
@@ -6426,8 +6396,8 @@
         </p:nvSpPr>
         <p:spPr>
           <a:xfrm>
-            <a:off x="9180576" y="2514600"/>
-            <a:ext cx="2468880" cy="731520"/>
+            <a:off x="9203436" y="2514600"/>
+            <a:ext cx="2560320" cy="685800"/>
           </a:xfrm>
           <a:prstGeom prst="rect">
             <a:avLst/>
@@ -6444,7 +6414,7 @@
             <a:r>
               <a:rPr sz="1300" b="0" i="0">
                 <a:solidFill>
-                  <a:srgbClr val="CBD5E1"/>
+                  <a:srgbClr val="94A3B8"/>
                 </a:solidFill>
               </a:rPr>
               <a:t>Risk score
@@ -6505,7 +6475,7 @@
         <p:spPr>
           <a:xfrm>
             <a:off x="548640" y="3520440"/>
-            <a:ext cx="10972800" cy="411480"/>
+            <a:ext cx="10972800" cy="365760"/>
           </a:xfrm>
           <a:prstGeom prst="rect">
             <a:avLst/>
@@ -6525,7 +6495,7 @@
                   <a:srgbClr val="FFFFFF"/>
                 </a:solidFill>
               </a:rPr>
-              <a:t>Key findings from demo environment:</a:t>
+              <a:t>Key findings:</a:t>
             </a:r>
           </a:p>
         </p:txBody>
@@ -6538,8 +6508,8 @@
         </p:nvSpPr>
         <p:spPr>
           <a:xfrm>
-            <a:off x="548640" y="3977639"/>
-            <a:ext cx="11064240" cy="2286000"/>
+            <a:off x="548640" y="3931920"/>
+            <a:ext cx="11064240" cy="2011680"/>
           </a:xfrm>
           <a:prstGeom prst="rect">
             <a:avLst/>
@@ -6554,91 +6524,61 @@
           <a:p>
             <a:pPr>
               <a:spcBef>
-                <a:spcPts val="500"/>
+                <a:spcPts val="600"/>
               </a:spcBef>
             </a:pPr>
             <a:r>
-              <a:rPr sz="1300">
+              <a:rPr sz="1400">
                 <a:solidFill>
                   <a:srgbClr val="F8FAFC"/>
                 </a:solidFill>
               </a:rPr>
-              <a:t>• SSH brute-force attempts detected and alerted within minutes (rule 5710, level 5)</a:t>
+              <a:t>• SSH brute-force detected within minutes (rule 5710)</a:t>
             </a:r>
           </a:p>
           <a:p>
             <a:pPr>
               <a:spcBef>
-                <a:spcPts val="500"/>
+                <a:spcPts val="600"/>
               </a:spcBef>
             </a:pPr>
             <a:r>
-              <a:rPr sz="1300">
+              <a:rPr sz="1400">
                 <a:solidFill>
                   <a:srgbClr val="F8FAFC"/>
                 </a:solidFill>
               </a:rPr>
-              <a:t>• PAM authentication failures flagged — rule 5503</a:t>
+              <a:t>• PAM auth failures flagged — rule 5503</a:t>
             </a:r>
           </a:p>
           <a:p>
             <a:pPr>
               <a:spcBef>
-                <a:spcPts val="500"/>
+                <a:spcPts val="600"/>
               </a:spcBef>
             </a:pPr>
             <a:r>
-              <a:rPr sz="1300">
+              <a:rPr sz="1400">
                 <a:solidFill>
                   <a:srgbClr val="F8FAFC"/>
                 </a:solidFill>
               </a:rPr>
-              <a:t>• Docker DNS resolution failures captured automatically by SCA</a:t>
+              <a:t>• Docker DNS and service failures captured automatically</a:t>
             </a:r>
           </a:p>
           <a:p>
             <a:pPr>
               <a:spcBef>
-                <a:spcPts val="500"/>
+                <a:spcPts val="600"/>
               </a:spcBef>
             </a:pPr>
             <a:r>
-              <a:rPr sz="1300">
+              <a:rPr sz="1400">
                 <a:solidFill>
                   <a:srgbClr val="F8FAFC"/>
                 </a:solidFill>
               </a:rPr>
-              <a:t>• Rancher agent service failures detected without manual intervention</a:t>
-            </a:r>
-          </a:p>
-          <a:p>
-            <a:pPr>
-              <a:spcBef>
-                <a:spcPts val="500"/>
-              </a:spcBef>
-            </a:pPr>
-            <a:r>
-              <a:rPr sz="1300">
-                <a:solidFill>
-                  <a:srgbClr val="F8FAFC"/>
-                </a:solidFill>
-              </a:rPr>
-              <a:t>• 373 CIS benchmark failures identified; 14 remediated post-hardening</a:t>
-            </a:r>
-          </a:p>
-          <a:p>
-            <a:pPr>
-              <a:spcBef>
-                <a:spcPts val="500"/>
-              </a:spcBef>
-            </a:pPr>
-            <a:r>
-              <a:rPr sz="1300">
-                <a:solidFill>
-                  <a:srgbClr val="F8FAFC"/>
-                </a:solidFill>
-              </a:rPr>
-              <a:t>• Before/after SCA comparison shows measurable improvement in security posture</a:t>
+              <a:t>• 373 CIS failures found; 14 remediated post-hardening</a:t>
             </a:r>
           </a:p>
         </p:txBody>
@@ -6651,8 +6591,8 @@
         </p:nvSpPr>
         <p:spPr>
           <a:xfrm>
-            <a:off x="548640" y="6080760"/>
-            <a:ext cx="11064240" cy="594360"/>
+            <a:off x="548640" y="6035040"/>
+            <a:ext cx="11064240" cy="640080"/>
           </a:xfrm>
           <a:prstGeom prst="rect">
             <a:avLst/>
@@ -6696,7 +6636,7 @@
         </p:nvSpPr>
         <p:spPr>
           <a:xfrm>
-            <a:off x="822960" y="6144768"/>
+            <a:off x="777240" y="6099048"/>
             <a:ext cx="10515600" cy="457200"/>
           </a:xfrm>
           <a:prstGeom prst="rect">
@@ -6717,7 +6657,7 @@
                   <a:srgbClr val="22C55E"/>
                 </a:solidFill>
               </a:rPr>
-              <a:t>Result: Ready for first customer pilot. We've already built and tested the full service flow.</a:t>
+              <a:t>Result: Ready for first customer pilot. Full service flow built and tested.</a:t>
             </a:r>
           </a:p>
         </p:txBody>
@@ -6756,8 +6696,8 @@
         </p:nvSpPr>
         <p:spPr>
           <a:xfrm>
-            <a:off x="548640" y="228600"/>
-            <a:ext cx="10972800" cy="640080"/>
+            <a:off x="548640" y="256032"/>
+            <a:ext cx="10972800" cy="731520"/>
           </a:xfrm>
           <a:prstGeom prst="rect">
             <a:avLst/>
@@ -6772,7 +6712,7 @@
           <a:p>
             <a:pPr algn="l"/>
             <a:r>
-              <a:rPr sz="3000" b="1" i="0">
+              <a:rPr sz="3200" b="1" i="0">
                 <a:solidFill>
                   <a:srgbClr val="F8FAFC"/>
                 </a:solidFill>
@@ -6790,8 +6730,8 @@
         </p:nvSpPr>
         <p:spPr>
           <a:xfrm>
-            <a:off x="548640" y="749808"/>
-            <a:ext cx="10972800" cy="320040"/>
+            <a:off x="548640" y="868680"/>
+            <a:ext cx="10972800" cy="365760"/>
           </a:xfrm>
           <a:prstGeom prst="rect">
             <a:avLst/>
@@ -6808,10 +6748,10 @@
             <a:r>
               <a:rPr sz="1400" b="0" i="0">
                 <a:solidFill>
-                  <a:srgbClr val="CBD5E1"/>
-                </a:solidFill>
-              </a:rPr>
-              <a:t>Narrow scope, fast results, no long-term commitment</a:t>
+                  <a:srgbClr val="94A3B8"/>
+                </a:solidFill>
+              </a:rPr>
+              <a:t>Narrow scope. Fast results. No long-term commitment.</a:t>
             </a:r>
           </a:p>
         </p:txBody>
@@ -6824,7 +6764,7 @@
         </p:nvSpPr>
         <p:spPr>
           <a:xfrm>
-            <a:off x="548640" y="1078992"/>
+            <a:off x="548640" y="1207008"/>
             <a:ext cx="11064240" cy="38100"/>
           </a:xfrm>
           <a:prstGeom prst="rect">
@@ -6867,8 +6807,8 @@
         </p:nvSpPr>
         <p:spPr>
           <a:xfrm>
-            <a:off x="548640" y="1371600"/>
-            <a:ext cx="5394960" cy="4206240"/>
+            <a:off x="548640" y="1417320"/>
+            <a:ext cx="5394960" cy="3657600"/>
           </a:xfrm>
           <a:prstGeom prst="rect">
             <a:avLst/>
@@ -6912,7 +6852,7 @@
         </p:nvSpPr>
         <p:spPr>
           <a:xfrm>
-            <a:off x="777240" y="1508760"/>
+            <a:off x="777240" y="1536192"/>
             <a:ext cx="4937760" cy="365760"/>
           </a:xfrm>
           <a:prstGeom prst="rect">
@@ -6933,7 +6873,7 @@
                   <a:srgbClr val="38BDF8"/>
                 </a:solidFill>
               </a:rPr>
-              <a:t>Pilot scope</a:t>
+              <a:t>What you get</a:t>
             </a:r>
           </a:p>
         </p:txBody>
@@ -6946,8 +6886,8 @@
         </p:nvSpPr>
         <p:spPr>
           <a:xfrm>
-            <a:off x="777240" y="1920240"/>
-            <a:ext cx="4937760" cy="2560320"/>
+            <a:off x="777240" y="1938528"/>
+            <a:ext cx="4937760" cy="2743200"/>
           </a:xfrm>
           <a:prstGeom prst="rect">
             <a:avLst/>
@@ -6971,7 +6911,7 @@
                   <a:srgbClr val="F8FAFC"/>
                 </a:solidFill>
               </a:rPr>
-              <a:t>• 3 to 10 critical Linux servers</a:t>
+              <a:t>• 3–10 critical Linux servers in scope</a:t>
             </a:r>
           </a:p>
           <a:p>
@@ -6986,7 +6926,7 @@
                   <a:srgbClr val="F8FAFC"/>
                 </a:solidFill>
               </a:rPr>
-              <a:t>• Monitoring deployment (Wazuh agents)</a:t>
+              <a:t>• Wazuh agent deployment + enrollment</a:t>
             </a:r>
           </a:p>
           <a:p>
@@ -7016,7 +6956,7 @@
                   <a:srgbClr val="F8FAFC"/>
                 </a:solidFill>
               </a:rPr>
-              <a:t>• Practical hardening improvements</a:t>
+              <a:t>• Practical hardening applied</a:t>
             </a:r>
           </a:p>
           <a:p>
@@ -7031,7 +6971,7 @@
                   <a:srgbClr val="F8FAFC"/>
                 </a:solidFill>
               </a:rPr>
-              <a:t>• Final management-ready report</a:t>
+              <a:t>• Management-ready final report</a:t>
             </a:r>
           </a:p>
         </p:txBody>
@@ -7044,8 +6984,8 @@
         </p:nvSpPr>
         <p:spPr>
           <a:xfrm>
-            <a:off x="6217920" y="1371600"/>
-            <a:ext cx="5394960" cy="4206240"/>
+            <a:off x="6217920" y="1417320"/>
+            <a:ext cx="5394960" cy="3657600"/>
           </a:xfrm>
           <a:prstGeom prst="rect">
             <a:avLst/>
@@ -7089,7 +7029,7 @@
         </p:nvSpPr>
         <p:spPr>
           <a:xfrm>
-            <a:off x="6446520" y="1508760"/>
+            <a:off x="6446520" y="1536192"/>
             <a:ext cx="4937760" cy="365760"/>
           </a:xfrm>
           <a:prstGeom prst="rect">
@@ -7110,7 +7050,7 @@
                   <a:srgbClr val="22C55E"/>
                 </a:solidFill>
               </a:rPr>
-              <a:t>Pilot outcome</a:t>
+              <a:t>What you decide at Day 30</a:t>
             </a:r>
           </a:p>
         </p:txBody>
@@ -7123,8 +7063,8 @@
         </p:nvSpPr>
         <p:spPr>
           <a:xfrm>
-            <a:off x="6446520" y="1920240"/>
-            <a:ext cx="4937760" cy="2743200"/>
+            <a:off x="6446520" y="1938528"/>
+            <a:ext cx="4937760" cy="2286000"/>
           </a:xfrm>
           <a:prstGeom prst="rect">
             <a:avLst/>
@@ -7148,7 +7088,7 @@
                   <a:srgbClr val="F8FAFC"/>
                 </a:solidFill>
               </a:rPr>
-              <a:t>• Clear visibility into what's happening on your systems</a:t>
+              <a:t>• Continue on a monthly service</a:t>
             </a:r>
           </a:p>
           <a:p>
@@ -7163,7 +7103,7 @@
                   <a:srgbClr val="F8FAFC"/>
                 </a:solidFill>
               </a:rPr>
-              <a:t>• Prioritized issues — know what matters most</a:t>
+              <a:t>• Expand scope to more systems</a:t>
             </a:r>
           </a:p>
           <a:p>
@@ -7178,22 +7118,7 @@
                   <a:srgbClr val="F8FAFC"/>
                 </a:solidFill>
               </a:rPr>
-              <a:t>• Security hygiene improvements applied</a:t>
-            </a:r>
-          </a:p>
-          <a:p>
-            <a:pPr>
-              <a:spcBef>
-                <a:spcPts val="800"/>
-              </a:spcBef>
-            </a:pPr>
-            <a:r>
-              <a:rPr sz="1400">
-                <a:solidFill>
-                  <a:srgbClr val="F8FAFC"/>
-                </a:solidFill>
-              </a:rPr>
-              <a:t>• Decision point: continue, expand, or stop</a:t>
+              <a:t>• Or stop — no lock-in required</a:t>
             </a:r>
           </a:p>
         </p:txBody>
@@ -7206,8 +7131,8 @@
         </p:nvSpPr>
         <p:spPr>
           <a:xfrm>
-            <a:off x="548640" y="5760720"/>
-            <a:ext cx="11064240" cy="914400"/>
+            <a:off x="548640" y="5257800"/>
+            <a:ext cx="11064240" cy="1325880"/>
           </a:xfrm>
           <a:prstGeom prst="rect">
             <a:avLst/>
@@ -7251,8 +7176,8 @@
         </p:nvSpPr>
         <p:spPr>
           <a:xfrm>
-            <a:off x="777240" y="5852160"/>
-            <a:ext cx="2011680" cy="320040"/>
+            <a:off x="777240" y="5367528"/>
+            <a:ext cx="1828800" cy="365760"/>
           </a:xfrm>
           <a:prstGeom prst="rect">
             <a:avLst/>
@@ -7285,8 +7210,8 @@
         </p:nvSpPr>
         <p:spPr>
           <a:xfrm>
-            <a:off x="2743200" y="5852160"/>
-            <a:ext cx="8686800" cy="320040"/>
+            <a:off x="2606040" y="5367528"/>
+            <a:ext cx="8686800" cy="365760"/>
           </a:xfrm>
           <a:prstGeom prst="rect">
             <a:avLst/>
@@ -7301,12 +7226,12 @@
           <a:p>
             <a:pPr algn="l"/>
             <a:r>
-              <a:rPr sz="1500" b="1" i="0">
+              <a:rPr sz="1800" b="1" i="0">
                 <a:solidFill>
                   <a:srgbClr val="FFFFFF"/>
                 </a:solidFill>
               </a:rPr>
-              <a:t>RM 2,000 – RM 5,000  (depending on scope and number of servers)</a:t>
+              <a:t>RM 2,000 – RM 5,000  (scope-dependent)</a:t>
             </a:r>
           </a:p>
         </p:txBody>
@@ -7319,8 +7244,8 @@
         </p:nvSpPr>
         <p:spPr>
           <a:xfrm>
-            <a:off x="777240" y="6172200"/>
-            <a:ext cx="10515600" cy="365760"/>
+            <a:off x="777240" y="5742432"/>
+            <a:ext cx="10515600" cy="457200"/>
           </a:xfrm>
           <a:prstGeom prst="rect">
             <a:avLst/>
@@ -7337,7 +7262,7 @@
             <a:r>
               <a:rPr sz="1200" b="0" i="1">
                 <a:solidFill>
-                  <a:srgbClr val="CBD5E1"/>
+                  <a:srgbClr val="94A3B8"/>
                 </a:solidFill>
               </a:rPr>
               <a:t>We keep the first engagement narrow on purpose — prove value fast, no transformation project required.</a:t>
@@ -7379,8 +7304,8 @@
         </p:nvSpPr>
         <p:spPr>
           <a:xfrm>
-            <a:off x="548640" y="228600"/>
-            <a:ext cx="10972800" cy="640080"/>
+            <a:off x="548640" y="256032"/>
+            <a:ext cx="10972800" cy="731520"/>
           </a:xfrm>
           <a:prstGeom prst="rect">
             <a:avLst/>
@@ -7395,7 +7320,7 @@
           <a:p>
             <a:pPr algn="l"/>
             <a:r>
-              <a:rPr sz="3000" b="1" i="0">
+              <a:rPr sz="3200" b="1" i="0">
                 <a:solidFill>
                   <a:srgbClr val="F8FAFC"/>
                 </a:solidFill>
@@ -7413,8 +7338,8 @@
         </p:nvSpPr>
         <p:spPr>
           <a:xfrm>
-            <a:off x="548640" y="749808"/>
-            <a:ext cx="10972800" cy="320040"/>
+            <a:off x="548640" y="868680"/>
+            <a:ext cx="10972800" cy="365760"/>
           </a:xfrm>
           <a:prstGeom prst="rect">
             <a:avLst/>
@@ -7431,10 +7356,10 @@
             <a:r>
               <a:rPr sz="1400" b="0" i="0">
                 <a:solidFill>
-                  <a:srgbClr val="CBD5E1"/>
-                </a:solidFill>
-              </a:rPr>
-              <a:t>Start narrow, prove value, expand based on real need</a:t>
+                  <a:srgbClr val="94A3B8"/>
+                </a:solidFill>
+              </a:rPr>
+              <a:t>Start narrow. Prove value. Expand based on real need.</a:t>
             </a:r>
           </a:p>
         </p:txBody>
@@ -7447,7 +7372,7 @@
         </p:nvSpPr>
         <p:spPr>
           <a:xfrm>
-            <a:off x="548640" y="1078992"/>
+            <a:off x="548640" y="1207008"/>
             <a:ext cx="11064240" cy="38100"/>
           </a:xfrm>
           <a:prstGeom prst="rect">
@@ -7490,8 +7415,8 @@
         </p:nvSpPr>
         <p:spPr>
           <a:xfrm>
-            <a:off x="745236" y="1371600"/>
-            <a:ext cx="3291840" cy="4754880"/>
+            <a:off x="772668" y="1417320"/>
+            <a:ext cx="3291840" cy="4572000"/>
           </a:xfrm>
           <a:prstGeom prst="rect">
             <a:avLst/>
@@ -7535,7 +7460,7 @@
         </p:nvSpPr>
         <p:spPr>
           <a:xfrm>
-            <a:off x="1110996" y="1508760"/>
+            <a:off x="1138428" y="1554480"/>
             <a:ext cx="2560320" cy="411480"/>
           </a:xfrm>
           <a:prstGeom prst="rect">
@@ -7563,7 +7488,7 @@
           </a:fontRef>
         </p:style>
         <p:txBody>
-          <a:bodyPr rtlCol="0" anchor="ctr" wrap="none"/>
+          <a:bodyPr rtlCol="0" anchor="ctr"/>
           <a:lstStyle/>
           <a:p>
             <a:pPr algn="ctr"/>
@@ -7586,7 +7511,7 @@
         </p:nvSpPr>
         <p:spPr>
           <a:xfrm>
-            <a:off x="882396" y="2011680"/>
+            <a:off x="909828" y="2057400"/>
             <a:ext cx="3017520" cy="411480"/>
           </a:xfrm>
           <a:prstGeom prst="rect">
@@ -7607,7 +7532,7 @@
                   <a:srgbClr val="FFFFFF"/>
                 </a:solidFill>
               </a:rPr>
-              <a:t>RM 1,500–2,500 / month</a:t>
+              <a:t>RM 1,500–2,500 / mo</a:t>
             </a:r>
           </a:p>
         </p:txBody>
@@ -7620,8 +7545,8 @@
         </p:nvSpPr>
         <p:spPr>
           <a:xfrm>
-            <a:off x="928116" y="2468880"/>
-            <a:ext cx="2926080" cy="3383280"/>
+            <a:off x="955548" y="2514600"/>
+            <a:ext cx="2926080" cy="3200400"/>
           </a:xfrm>
           <a:prstGeom prst="rect">
             <a:avLst/>
@@ -7645,7 +7570,7 @@
                   <a:srgbClr val="F8FAFC"/>
                 </a:solidFill>
               </a:rPr>
-              <a:t>• Smaller environments and limited scope</a:t>
+              <a:t>• Smaller environments</a:t>
             </a:r>
           </a:p>
           <a:p>
@@ -7660,7 +7585,7 @@
                   <a:srgbClr val="F8FAFC"/>
                 </a:solidFill>
               </a:rPr>
-              <a:t>• Managed monitoring (up to 5 agents)</a:t>
+              <a:t>• Up to 5 agents</a:t>
             </a:r>
           </a:p>
           <a:p>
@@ -7718,8 +7643,8 @@
         </p:nvSpPr>
         <p:spPr>
           <a:xfrm>
-            <a:off x="4448556" y="1371600"/>
-            <a:ext cx="3291840" cy="4754880"/>
+            <a:off x="4448556" y="1417320"/>
+            <a:ext cx="3291840" cy="4572000"/>
           </a:xfrm>
           <a:prstGeom prst="rect">
             <a:avLst/>
@@ -7763,7 +7688,7 @@
         </p:nvSpPr>
         <p:spPr>
           <a:xfrm>
-            <a:off x="4814316" y="1508760"/>
+            <a:off x="4814316" y="1554480"/>
             <a:ext cx="2560320" cy="411480"/>
           </a:xfrm>
           <a:prstGeom prst="rect">
@@ -7791,7 +7716,7 @@
           </a:fontRef>
         </p:style>
         <p:txBody>
-          <a:bodyPr rtlCol="0" anchor="ctr" wrap="none"/>
+          <a:bodyPr rtlCol="0" anchor="ctr"/>
           <a:lstStyle/>
           <a:p>
             <a:pPr algn="ctr"/>
@@ -7814,7 +7739,7 @@
         </p:nvSpPr>
         <p:spPr>
           <a:xfrm>
-            <a:off x="4585716" y="2011680"/>
+            <a:off x="4585716" y="2057400"/>
             <a:ext cx="3017520" cy="411480"/>
           </a:xfrm>
           <a:prstGeom prst="rect">
@@ -7835,7 +7760,7 @@
                   <a:srgbClr val="FFFFFF"/>
                 </a:solidFill>
               </a:rPr>
-              <a:t>RM 3,000–5,000 / month</a:t>
+              <a:t>RM 3,000–5,000 / mo</a:t>
             </a:r>
           </a:p>
         </p:txBody>
@@ -7848,8 +7773,8 @@
         </p:nvSpPr>
         <p:spPr>
           <a:xfrm>
-            <a:off x="4631436" y="2468880"/>
-            <a:ext cx="2926080" cy="3383280"/>
+            <a:off x="4631436" y="2514600"/>
+            <a:ext cx="2926080" cy="3200400"/>
           </a:xfrm>
           <a:prstGeom prst="rect">
             <a:avLst/>
@@ -7873,7 +7798,7 @@
                   <a:srgbClr val="F8FAFC"/>
                 </a:solidFill>
               </a:rPr>
-              <a:t>• Best fit for most production teams</a:t>
+              <a:t>• Most production teams</a:t>
             </a:r>
           </a:p>
           <a:p>
@@ -7888,7 +7813,7 @@
                   <a:srgbClr val="F8FAFC"/>
                 </a:solidFill>
               </a:rPr>
-              <a:t>• Managed monitoring (up to 15 agents)</a:t>
+              <a:t>• Up to 15 agents</a:t>
             </a:r>
           </a:p>
           <a:p>
@@ -7903,7 +7828,7 @@
                   <a:srgbClr val="F8FAFC"/>
                 </a:solidFill>
               </a:rPr>
-              <a:t>• Proactive hardening (monthly)</a:t>
+              <a:t>• Proactive monthly hardening</a:t>
             </a:r>
           </a:p>
           <a:p>
@@ -7948,7 +7873,7 @@
                   <a:srgbClr val="F8FAFC"/>
                 </a:solidFill>
               </a:rPr>
-              <a:t>• Priority email/chat support</a:t>
+              <a:t>• Priority support</a:t>
             </a:r>
           </a:p>
         </p:txBody>
@@ -7961,8 +7886,8 @@
         </p:nvSpPr>
         <p:spPr>
           <a:xfrm>
-            <a:off x="8151876" y="1371600"/>
-            <a:ext cx="3291840" cy="4754880"/>
+            <a:off x="8124444" y="1417320"/>
+            <a:ext cx="3291840" cy="4572000"/>
           </a:xfrm>
           <a:prstGeom prst="rect">
             <a:avLst/>
@@ -8006,7 +7931,7 @@
         </p:nvSpPr>
         <p:spPr>
           <a:xfrm>
-            <a:off x="8517636" y="1508760"/>
+            <a:off x="8490204" y="1554480"/>
             <a:ext cx="2560320" cy="411480"/>
           </a:xfrm>
           <a:prstGeom prst="rect">
@@ -8034,7 +7959,7 @@
           </a:fontRef>
         </p:style>
         <p:txBody>
-          <a:bodyPr rtlCol="0" anchor="ctr" wrap="none"/>
+          <a:bodyPr rtlCol="0" anchor="ctr"/>
           <a:lstStyle/>
           <a:p>
             <a:pPr algn="ctr"/>
@@ -8057,7 +7982,7 @@
         </p:nvSpPr>
         <p:spPr>
           <a:xfrm>
-            <a:off x="8289036" y="2011680"/>
+            <a:off x="8261604" y="2057400"/>
             <a:ext cx="3017520" cy="411480"/>
           </a:xfrm>
           <a:prstGeom prst="rect">
@@ -8091,8 +8016,8 @@
         </p:nvSpPr>
         <p:spPr>
           <a:xfrm>
-            <a:off x="8334756" y="2468880"/>
-            <a:ext cx="2926080" cy="3383280"/>
+            <a:off x="8307324" y="2514600"/>
+            <a:ext cx="2926080" cy="3200400"/>
           </a:xfrm>
           <a:prstGeom prst="rect">
             <a:avLst/>
@@ -8116,7 +8041,7 @@
                   <a:srgbClr val="F8FAFC"/>
                 </a:solidFill>
               </a:rPr>
-              <a:t>• Stronger reporting and compliance scope</a:t>
+              <a:t>• Stronger compliance scope</a:t>
             </a:r>
           </a:p>
           <a:p>
@@ -8176,7 +8101,7 @@
                   <a:srgbClr val="F8FAFC"/>
                 </a:solidFill>
               </a:rPr>
-              <a:t>• Dedicated part-time analyst</a:t>
+              <a:t>• Dedicated analyst (PT)</a:t>
             </a:r>
           </a:p>
           <a:p>
@@ -8204,7 +8129,7 @@
         </p:nvSpPr>
         <p:spPr>
           <a:xfrm>
-            <a:off x="548640" y="6126480"/>
+            <a:off x="548640" y="6172200"/>
             <a:ext cx="11064240" cy="365760"/>
           </a:xfrm>
           <a:prstGeom prst="rect">
@@ -8222,7 +8147,7 @@
             <a:r>
               <a:rPr sz="1100" b="0" i="1">
                 <a:solidFill>
-                  <a:srgbClr val="CBD5E1"/>
+                  <a:srgbClr val="94A3B8"/>
                 </a:solidFill>
               </a:rPr>
               <a:t>* All tiers include PDPA-aligned reporting. Custom scopes available on request.</a:t>
@@ -8264,7 +8189,7 @@
         </p:nvSpPr>
         <p:spPr>
           <a:xfrm>
-            <a:off x="640080" y="1371600"/>
+            <a:off x="640080" y="1280160"/>
             <a:ext cx="10972800" cy="822960"/>
           </a:xfrm>
           <a:prstGeom prst="rect">
@@ -8280,7 +8205,7 @@
           <a:p>
             <a:pPr algn="l"/>
             <a:r>
-              <a:rPr sz="3800" b="1" i="0">
+              <a:rPr sz="4000" b="1" i="0">
                 <a:solidFill>
                   <a:srgbClr val="FFFFFF"/>
                 </a:solidFill>
@@ -8298,8 +8223,8 @@
         </p:nvSpPr>
         <p:spPr>
           <a:xfrm>
-            <a:off x="640080" y="2286000"/>
-            <a:ext cx="10972800" cy="548640"/>
+            <a:off x="640080" y="2194560"/>
+            <a:ext cx="10972800" cy="502920"/>
           </a:xfrm>
           <a:prstGeom prst="rect">
             <a:avLst/>
@@ -8316,10 +8241,10 @@
             <a:r>
               <a:rPr sz="2000" b="0" i="0">
                 <a:solidFill>
-                  <a:srgbClr val="CBD5E1"/>
-                </a:solidFill>
-              </a:rPr>
-              <a:t>The first step is a 20-minute discovery call — no pitch, no pressure.</a:t>
+                  <a:srgbClr val="94A3B8"/>
+                </a:solidFill>
+              </a:rPr>
+              <a:t>20-minute discovery call — no pitch, no pressure.</a:t>
             </a:r>
           </a:p>
         </p:txBody>
@@ -8332,7 +8257,7 @@
         </p:nvSpPr>
         <p:spPr>
           <a:xfrm>
-            <a:off x="640080" y="2971800"/>
+            <a:off x="640080" y="2834640"/>
             <a:ext cx="3657600" cy="38100"/>
           </a:xfrm>
           <a:prstGeom prst="rect">
@@ -8375,8 +8300,8 @@
         </p:nvSpPr>
         <p:spPr>
           <a:xfrm>
-            <a:off x="676656" y="3246120"/>
-            <a:ext cx="2468880" cy="1737360"/>
+            <a:off x="544068" y="3108960"/>
+            <a:ext cx="2514600" cy="1645920"/>
           </a:xfrm>
           <a:prstGeom prst="rect">
             <a:avLst/>
@@ -8420,8 +8345,8 @@
         </p:nvSpPr>
         <p:spPr>
           <a:xfrm>
-            <a:off x="813816" y="3337560"/>
-            <a:ext cx="2194560" cy="365760"/>
+            <a:off x="681228" y="3200400"/>
+            <a:ext cx="2240280" cy="365760"/>
           </a:xfrm>
           <a:prstGeom prst="rect">
             <a:avLst/>
@@ -8454,8 +8379,8 @@
         </p:nvSpPr>
         <p:spPr>
           <a:xfrm>
-            <a:off x="813816" y="3749039"/>
-            <a:ext cx="2194560" cy="1005840"/>
+            <a:off x="681228" y="3611880"/>
+            <a:ext cx="2240280" cy="914400"/>
           </a:xfrm>
           <a:prstGeom prst="rect">
             <a:avLst/>
@@ -8475,7 +8400,7 @@
                   <a:srgbClr val="F8FAFC"/>
                 </a:solidFill>
               </a:rPr>
-              <a:t>Assess your Linux/cloud workload scope and complexity</a:t>
+              <a:t>Assess Linux/cloud workload scope</a:t>
             </a:r>
           </a:p>
         </p:txBody>
@@ -8488,8 +8413,8 @@
         </p:nvSpPr>
         <p:spPr>
           <a:xfrm>
-            <a:off x="3465576" y="3246120"/>
-            <a:ext cx="2468880" cy="1737360"/>
+            <a:off x="3406140" y="3108960"/>
+            <a:ext cx="2514600" cy="1645920"/>
           </a:xfrm>
           <a:prstGeom prst="rect">
             <a:avLst/>
@@ -8533,8 +8458,8 @@
         </p:nvSpPr>
         <p:spPr>
           <a:xfrm>
-            <a:off x="3602736" y="3337560"/>
-            <a:ext cx="2194560" cy="365760"/>
+            <a:off x="3543300" y="3200400"/>
+            <a:ext cx="2240280" cy="365760"/>
           </a:xfrm>
           <a:prstGeom prst="rect">
             <a:avLst/>
@@ -8567,8 +8492,8 @@
         </p:nvSpPr>
         <p:spPr>
           <a:xfrm>
-            <a:off x="3602736" y="3749039"/>
-            <a:ext cx="2194560" cy="1005840"/>
+            <a:off x="3543300" y="3611880"/>
+            <a:ext cx="2240280" cy="914400"/>
           </a:xfrm>
           <a:prstGeom prst="rect">
             <a:avLst/>
@@ -8588,7 +8513,7 @@
                   <a:srgbClr val="F8FAFC"/>
                 </a:solidFill>
               </a:rPr>
-              <a:t>Identify which servers and services matter most</a:t>
+              <a:t>Identify what matters most</a:t>
             </a:r>
           </a:p>
         </p:txBody>
@@ -8601,8 +8526,8 @@
         </p:nvSpPr>
         <p:spPr>
           <a:xfrm>
-            <a:off x="6254496" y="3246120"/>
-            <a:ext cx="2468880" cy="1737360"/>
+            <a:off x="6268212" y="3108960"/>
+            <a:ext cx="2514600" cy="1645920"/>
           </a:xfrm>
           <a:prstGeom prst="rect">
             <a:avLst/>
@@ -8646,8 +8571,8 @@
         </p:nvSpPr>
         <p:spPr>
           <a:xfrm>
-            <a:off x="6391656" y="3337560"/>
-            <a:ext cx="2194560" cy="365760"/>
+            <a:off x="6405372" y="3200400"/>
+            <a:ext cx="2240280" cy="365760"/>
           </a:xfrm>
           <a:prstGeom prst="rect">
             <a:avLst/>
@@ -8680,8 +8605,8 @@
         </p:nvSpPr>
         <p:spPr>
           <a:xfrm>
-            <a:off x="6391656" y="3749039"/>
-            <a:ext cx="2194560" cy="1005840"/>
+            <a:off x="6405372" y="3611880"/>
+            <a:ext cx="2240280" cy="914400"/>
           </a:xfrm>
           <a:prstGeom prst="rect">
             <a:avLst/>
@@ -8701,7 +8626,7 @@
                   <a:srgbClr val="F8FAFC"/>
                 </a:solidFill>
               </a:rPr>
-              <a:t>Map where security blind spots exist today</a:t>
+              <a:t>Map security blind spots</a:t>
             </a:r>
           </a:p>
         </p:txBody>
@@ -8714,8 +8639,8 @@
         </p:nvSpPr>
         <p:spPr>
           <a:xfrm>
-            <a:off x="9043416" y="3246120"/>
-            <a:ext cx="2468880" cy="1737360"/>
+            <a:off x="9130284" y="3108960"/>
+            <a:ext cx="2514600" cy="1645920"/>
           </a:xfrm>
           <a:prstGeom prst="rect">
             <a:avLst/>
@@ -8759,8 +8684,8 @@
         </p:nvSpPr>
         <p:spPr>
           <a:xfrm>
-            <a:off x="9180576" y="3337560"/>
-            <a:ext cx="2194560" cy="365760"/>
+            <a:off x="9267444" y="3200400"/>
+            <a:ext cx="2240280" cy="365760"/>
           </a:xfrm>
           <a:prstGeom prst="rect">
             <a:avLst/>
@@ -8793,8 +8718,8 @@
         </p:nvSpPr>
         <p:spPr>
           <a:xfrm>
-            <a:off x="9180576" y="3749039"/>
-            <a:ext cx="2194560" cy="1005840"/>
+            <a:off x="9267444" y="3611880"/>
+            <a:ext cx="2240280" cy="914400"/>
           </a:xfrm>
           <a:prstGeom prst="rect">
             <a:avLst/>
@@ -8814,7 +8739,7 @@
                   <a:srgbClr val="F8FAFC"/>
                 </a:solidFill>
               </a:rPr>
-              <a:t>Confirm if the 30-day pilot is the right first step</a:t>
+              <a:t>Confirm fit for 30-day pilot</a:t>
             </a:r>
           </a:p>
         </p:txBody>
@@ -8827,7 +8752,7 @@
         </p:nvSpPr>
         <p:spPr>
           <a:xfrm>
-            <a:off x="640080" y="5166360"/>
+            <a:off x="640080" y="4937760"/>
             <a:ext cx="11064240" cy="38100"/>
           </a:xfrm>
           <a:prstGeom prst="rect">
@@ -8870,7 +8795,7 @@
         </p:nvSpPr>
         <p:spPr>
           <a:xfrm>
-            <a:off x="640080" y="5349240"/>
+            <a:off x="640080" y="5120640"/>
             <a:ext cx="10972800" cy="411480"/>
           </a:xfrm>
           <a:prstGeom prst="rect">
@@ -8904,7 +8829,7 @@
         </p:nvSpPr>
         <p:spPr>
           <a:xfrm>
-            <a:off x="640080" y="5897880"/>
+            <a:off x="640080" y="5669280"/>
             <a:ext cx="10972800" cy="411480"/>
           </a:xfrm>
           <a:prstGeom prst="rect">
@@ -8938,7 +8863,7 @@
         </p:nvSpPr>
         <p:spPr>
           <a:xfrm>
-            <a:off x="640080" y="6263640"/>
+            <a:off x="640080" y="6035040"/>
             <a:ext cx="10972800" cy="320040"/>
           </a:xfrm>
           <a:prstGeom prst="rect">
@@ -8956,10 +8881,10 @@
             <a:r>
               <a:rPr sz="1300" b="0" i="0">
                 <a:solidFill>
-                  <a:srgbClr val="CBD5E1"/>
-                </a:solidFill>
-              </a:rPr>
-              <a:t>[email@domain.com]   |   [WhatsApp]   |   [LinkedIn]</a:t>
+                  <a:srgbClr val="94A3B8"/>
+                </a:solidFill>
+              </a:rPr>
+              <a:t>[email]   [WhatsApp]   [LinkedIn]</a:t>
             </a:r>
           </a:p>
         </p:txBody>

</xml_diff>